<commit_message>
Corrige compatibilidade visual do mapa na Aula 0.1
</commit_message>
<xml_diff>
--- a/70 - Produções/Cursos/Curso - Nome Provisório/Materiais/Aula 0.1/Aula 0.1 - Por que Traduzir a Experiência Humana.pptx
+++ b/70 - Produções/Cursos/Curso - Nome Provisório/Materiais/Aula 0.1/Aula 0.1 - Por que Traduzir a Experiência Humana.pptx
@@ -2,24 +2,24 @@
 <file path=ppt/presentation.xml><?xml version="1.0" encoding="utf-8"?>
 <p:presentation xmlns:p="http://schemas.openxmlformats.org/presentationml/2006/main">
   <p:sldMasterIdLst>
-    <p:sldMasterId xmlns:r="http://schemas.openxmlformats.org/officeDocument/2006/relationships" id="2147483648" r:id="Rb3f0b332912c4c64"/>
+    <p:sldMasterId xmlns:r="http://schemas.openxmlformats.org/officeDocument/2006/relationships" id="2147483648" r:id="Rf0368aff46bc4570"/>
   </p:sldMasterIdLst>
   <p:notesMasterIdLst>
-    <p:notesMasterId xmlns:r="http://schemas.openxmlformats.org/officeDocument/2006/relationships" r:id="R02738e302c314c06"/>
+    <p:notesMasterId xmlns:r="http://schemas.openxmlformats.org/officeDocument/2006/relationships" r:id="R752bce22f2f04eae"/>
   </p:notesMasterIdLst>
   <p:sldIdLst>
-    <p:sldId xmlns:r="http://schemas.openxmlformats.org/officeDocument/2006/relationships" id="256" r:id="R89bb4759e65e4c49"/>
-    <p:sldId xmlns:r="http://schemas.openxmlformats.org/officeDocument/2006/relationships" id="257" r:id="Rc441225f404449b0"/>
-    <p:sldId xmlns:r="http://schemas.openxmlformats.org/officeDocument/2006/relationships" id="258" r:id="Rd00bf1c08219473c"/>
-    <p:sldId xmlns:r="http://schemas.openxmlformats.org/officeDocument/2006/relationships" id="259" r:id="Re51a72746ebb4ae7"/>
-    <p:sldId xmlns:r="http://schemas.openxmlformats.org/officeDocument/2006/relationships" id="260" r:id="R52868db165ff4730"/>
-    <p:sldId xmlns:r="http://schemas.openxmlformats.org/officeDocument/2006/relationships" id="261" r:id="R4a4c1c3af1064f11"/>
-    <p:sldId xmlns:r="http://schemas.openxmlformats.org/officeDocument/2006/relationships" id="262" r:id="R13080283318741b5"/>
-    <p:sldId xmlns:r="http://schemas.openxmlformats.org/officeDocument/2006/relationships" id="263" r:id="Rd544e36b34fb4e2a"/>
-    <p:sldId xmlns:r="http://schemas.openxmlformats.org/officeDocument/2006/relationships" id="264" r:id="R0930ed878cf14866"/>
-    <p:sldId xmlns:r="http://schemas.openxmlformats.org/officeDocument/2006/relationships" id="265" r:id="R02d7634ba59247d0"/>
-    <p:sldId xmlns:r="http://schemas.openxmlformats.org/officeDocument/2006/relationships" id="266" r:id="Rb05e37ab5a664d3c"/>
-    <p:sldId xmlns:r="http://schemas.openxmlformats.org/officeDocument/2006/relationships" id="267" r:id="Rd829801248ed4f5e"/>
+    <p:sldId xmlns:r="http://schemas.openxmlformats.org/officeDocument/2006/relationships" id="256" r:id="R85dd72c7cce94a98"/>
+    <p:sldId xmlns:r="http://schemas.openxmlformats.org/officeDocument/2006/relationships" id="257" r:id="R39ad6a316d444ef1"/>
+    <p:sldId xmlns:r="http://schemas.openxmlformats.org/officeDocument/2006/relationships" id="258" r:id="R8cba4cb1aa4b44d3"/>
+    <p:sldId xmlns:r="http://schemas.openxmlformats.org/officeDocument/2006/relationships" id="259" r:id="Re51d77e85fdd4084"/>
+    <p:sldId xmlns:r="http://schemas.openxmlformats.org/officeDocument/2006/relationships" id="260" r:id="R1772b09ce8184430"/>
+    <p:sldId xmlns:r="http://schemas.openxmlformats.org/officeDocument/2006/relationships" id="261" r:id="Reffc056478784ab1"/>
+    <p:sldId xmlns:r="http://schemas.openxmlformats.org/officeDocument/2006/relationships" id="262" r:id="Rfb5f26d950fd4a1b"/>
+    <p:sldId xmlns:r="http://schemas.openxmlformats.org/officeDocument/2006/relationships" id="263" r:id="R3aae9fa6e2494a79"/>
+    <p:sldId xmlns:r="http://schemas.openxmlformats.org/officeDocument/2006/relationships" id="264" r:id="Rc05ab5a672df471f"/>
+    <p:sldId xmlns:r="http://schemas.openxmlformats.org/officeDocument/2006/relationships" id="265" r:id="Rea881587d361442e"/>
+    <p:sldId xmlns:r="http://schemas.openxmlformats.org/officeDocument/2006/relationships" id="266" r:id="R89d6579c14bc49cd"/>
+    <p:sldId xmlns:r="http://schemas.openxmlformats.org/officeDocument/2006/relationships" id="267" r:id="Rb8a59883e88f4c15"/>
   </p:sldIdLst>
   <p:sldSz cx="12192000" cy="6858000"/>
   <p:notesSz cx="6858000" cy="9144000"/>
@@ -1386,7 +1386,7 @@
   </p:cSld>
   <p:clrMap bg1="lt1" tx1="dk1" bg2="lt2" tx2="dk2" accent1="accent1" accent2="accent2" accent3="accent3" accent4="accent4" accent5="accent5" accent6="accent6" hlink="hlink" folHlink="folHlink"/>
   <p:sldLayoutIdLst>
-    <p:sldLayoutId xmlns:r="http://schemas.openxmlformats.org/officeDocument/2006/relationships" id="2147483649" r:id="Rbe533c2222944862"/>
+    <p:sldLayoutId xmlns:r="http://schemas.openxmlformats.org/officeDocument/2006/relationships" id="2147483649" r:id="Ra66514367b8b48e2"/>
   </p:sldLayoutIdLst>
   <p:txStyles>
     <p:titleStyle>
@@ -1937,7 +1937,7 @@
           <p:cNvPr id="1" name="">
             <a:extLst xmlns:a="http://schemas.openxmlformats.org/drawingml/2006/main">
               <a:ext uri="{FF2B5EF4-FFF2-40B4-BE49-F238E27FC236}">
-                <a16:creationId xmlns:a16="http://schemas.microsoft.com/office/drawing/2014/main" id="{23F0CD7A-B111-4982-A04F-66A5E710DA9A}"/>
+                <a16:creationId xmlns:a16="http://schemas.microsoft.com/office/drawing/2014/main" id="{E1F684E9-F064-4A18-9EFB-087232BFC9ED}"/>
               </a:ext>
             </a:extLst>
           </p:cNvPr>
@@ -1968,7 +1968,7 @@
           <p:cNvPr id="2" name="">
             <a:extLst xmlns:a="http://schemas.openxmlformats.org/drawingml/2006/main">
               <a:ext uri="{FF2B5EF4-FFF2-40B4-BE49-F238E27FC236}">
-                <a16:creationId xmlns:a16="http://schemas.microsoft.com/office/drawing/2014/main" id="{1488A4E3-DBD1-4E04-8580-CED3573677BB}"/>
+                <a16:creationId xmlns:a16="http://schemas.microsoft.com/office/drawing/2014/main" id="{7EC24D38-2820-401A-82AC-761608F317B6}"/>
               </a:ext>
             </a:extLst>
           </p:cNvPr>
@@ -2018,7 +2018,7 @@
           <p:cNvPr id="3" name="">
             <a:extLst xmlns:a="http://schemas.openxmlformats.org/drawingml/2006/main">
               <a:ext uri="{FF2B5EF4-FFF2-40B4-BE49-F238E27FC236}">
-                <a16:creationId xmlns:a16="http://schemas.microsoft.com/office/drawing/2014/main" id="{61943CC8-D627-4426-9A21-5E80EA60D72E}"/>
+                <a16:creationId xmlns:a16="http://schemas.microsoft.com/office/drawing/2014/main" id="{03FB0382-5370-4AA0-9BEB-5909E46B5382}"/>
               </a:ext>
             </a:extLst>
           </p:cNvPr>
@@ -2085,7 +2085,7 @@
           <p:cNvPr id="4" name="">
             <a:extLst xmlns:a="http://schemas.openxmlformats.org/drawingml/2006/main">
               <a:ext uri="{FF2B5EF4-FFF2-40B4-BE49-F238E27FC236}">
-                <a16:creationId xmlns:a16="http://schemas.microsoft.com/office/drawing/2014/main" id="{9E015699-0A9E-4D3D-BB99-C7AE411B15B2}"/>
+                <a16:creationId xmlns:a16="http://schemas.microsoft.com/office/drawing/2014/main" id="{8249F42F-EB69-4289-9247-43A081E545E6}"/>
               </a:ext>
             </a:extLst>
           </p:cNvPr>
@@ -2135,7 +2135,7 @@
           <p:cNvPr id="5" name="">
             <a:extLst xmlns:a="http://schemas.openxmlformats.org/drawingml/2006/main">
               <a:ext uri="{FF2B5EF4-FFF2-40B4-BE49-F238E27FC236}">
-                <a16:creationId xmlns:a16="http://schemas.microsoft.com/office/drawing/2014/main" id="{3053E16D-CF1E-4F4E-A572-B4797D05C872}"/>
+                <a16:creationId xmlns:a16="http://schemas.microsoft.com/office/drawing/2014/main" id="{68C7AB25-576D-4D95-9C87-3B866E3D601A}"/>
               </a:ext>
             </a:extLst>
           </p:cNvPr>
@@ -2168,7 +2168,7 @@
           <p:cNvPr id="6" name="">
             <a:extLst xmlns:a="http://schemas.openxmlformats.org/drawingml/2006/main">
               <a:ext uri="{FF2B5EF4-FFF2-40B4-BE49-F238E27FC236}">
-                <a16:creationId xmlns:a16="http://schemas.microsoft.com/office/drawing/2014/main" id="{5A1B5952-8208-477D-962A-50640A8A42F0}"/>
+                <a16:creationId xmlns:a16="http://schemas.microsoft.com/office/drawing/2014/main" id="{BA35D086-6DBB-4393-8D76-FE9BD1B5DC4A}"/>
               </a:ext>
             </a:extLst>
           </p:cNvPr>
@@ -2240,7 +2240,7 @@
           <p:cNvPr id="7" name="">
             <a:extLst xmlns:a="http://schemas.openxmlformats.org/drawingml/2006/main">
               <a:ext uri="{FF2B5EF4-FFF2-40B4-BE49-F238E27FC236}">
-                <a16:creationId xmlns:a16="http://schemas.microsoft.com/office/drawing/2014/main" id="{0C173200-DB5D-4F84-8D34-37AD23CA07B7}"/>
+                <a16:creationId xmlns:a16="http://schemas.microsoft.com/office/drawing/2014/main" id="{D382D558-5F31-4AB6-9008-69E9E2E86538}"/>
               </a:ext>
             </a:extLst>
           </p:cNvPr>
@@ -2290,7 +2290,7 @@
           <p:cNvPr id="8" name="">
             <a:extLst xmlns:a="http://schemas.openxmlformats.org/drawingml/2006/main">
               <a:ext uri="{FF2B5EF4-FFF2-40B4-BE49-F238E27FC236}">
-                <a16:creationId xmlns:a16="http://schemas.microsoft.com/office/drawing/2014/main" id="{FF62FFD8-E83B-46CE-B8CE-E7A9DA25D80B}"/>
+                <a16:creationId xmlns:a16="http://schemas.microsoft.com/office/drawing/2014/main" id="{8286D844-7562-483A-81A1-DB1355B6FBAA}"/>
               </a:ext>
             </a:extLst>
           </p:cNvPr>
@@ -2338,7 +2338,7 @@
     </p:spTree>
     <p:extLst>
       <p:ext uri="{BB962C8B-B14F-4D97-AF65-F5344CB8AC3E}">
-        <p14:creationId xmlns:p14="http://schemas.microsoft.com/office/powerpoint/2010/main" val="55658324"/>
+        <p14:creationId xmlns:p14="http://schemas.microsoft.com/office/powerpoint/2010/main" val="879257215"/>
       </p:ext>
     </p:extLst>
   </p:cSld>
@@ -2369,7 +2369,7 @@
           <p:cNvPr id="1" name="">
             <a:extLst xmlns:a="http://schemas.openxmlformats.org/drawingml/2006/main">
               <a:ext uri="{FF2B5EF4-FFF2-40B4-BE49-F238E27FC236}">
-                <a16:creationId xmlns:a16="http://schemas.microsoft.com/office/drawing/2014/main" id="{7FAA8362-B375-45F1-BBAC-F4A27F11C843}"/>
+                <a16:creationId xmlns:a16="http://schemas.microsoft.com/office/drawing/2014/main" id="{1263BB37-F41A-4B0C-9E15-4D41DA99ECDA}"/>
               </a:ext>
             </a:extLst>
           </p:cNvPr>
@@ -2419,7 +2419,7 @@
           <p:cNvPr id="2" name="">
             <a:extLst xmlns:a="http://schemas.openxmlformats.org/drawingml/2006/main">
               <a:ext uri="{FF2B5EF4-FFF2-40B4-BE49-F238E27FC236}">
-                <a16:creationId xmlns:a16="http://schemas.microsoft.com/office/drawing/2014/main" id="{2BEAB821-91A2-4888-A3F3-028B098F00D1}"/>
+                <a16:creationId xmlns:a16="http://schemas.microsoft.com/office/drawing/2014/main" id="{4EC9F8B2-1F03-498F-ACEA-3C6AA22E39F2}"/>
               </a:ext>
             </a:extLst>
           </p:cNvPr>
@@ -2469,7 +2469,7 @@
           <p:cNvPr id="3" name="">
             <a:extLst xmlns:a="http://schemas.openxmlformats.org/drawingml/2006/main">
               <a:ext uri="{FF2B5EF4-FFF2-40B4-BE49-F238E27FC236}">
-                <a16:creationId xmlns:a16="http://schemas.microsoft.com/office/drawing/2014/main" id="{454D90A9-00FB-49AB-BEC9-D15446F56863}"/>
+                <a16:creationId xmlns:a16="http://schemas.microsoft.com/office/drawing/2014/main" id="{B822D4B1-002D-41E5-A851-EA36FA8E6B83}"/>
               </a:ext>
             </a:extLst>
           </p:cNvPr>
@@ -2500,7 +2500,7 @@
           <p:cNvPr id="4" name="">
             <a:extLst xmlns:a="http://schemas.openxmlformats.org/drawingml/2006/main">
               <a:ext uri="{FF2B5EF4-FFF2-40B4-BE49-F238E27FC236}">
-                <a16:creationId xmlns:a16="http://schemas.microsoft.com/office/drawing/2014/main" id="{7859357D-FC8A-49F7-9B03-D0F7FA681D64}"/>
+                <a16:creationId xmlns:a16="http://schemas.microsoft.com/office/drawing/2014/main" id="{E7127829-AFA1-4DC3-B032-61BCB91BD11F}"/>
               </a:ext>
             </a:extLst>
           </p:cNvPr>
@@ -2550,7 +2550,7 @@
           <p:cNvPr id="5" name="">
             <a:extLst xmlns:a="http://schemas.openxmlformats.org/drawingml/2006/main">
               <a:ext uri="{FF2B5EF4-FFF2-40B4-BE49-F238E27FC236}">
-                <a16:creationId xmlns:a16="http://schemas.microsoft.com/office/drawing/2014/main" id="{C557EAFA-16FA-418B-A2F7-E73FF79A7A54}"/>
+                <a16:creationId xmlns:a16="http://schemas.microsoft.com/office/drawing/2014/main" id="{DDCAE12A-3DCB-441A-B5A7-C29F0F7139BB}"/>
               </a:ext>
             </a:extLst>
           </p:cNvPr>
@@ -2585,7 +2585,7 @@
           <p:cNvPr id="6" name="">
             <a:extLst xmlns:a="http://schemas.openxmlformats.org/drawingml/2006/main">
               <a:ext uri="{FF2B5EF4-FFF2-40B4-BE49-F238E27FC236}">
-                <a16:creationId xmlns:a16="http://schemas.microsoft.com/office/drawing/2014/main" id="{64EC84AC-B02D-4218-8256-34787D54527C}"/>
+                <a16:creationId xmlns:a16="http://schemas.microsoft.com/office/drawing/2014/main" id="{A754656A-1067-4074-9438-41B42DFCA669}"/>
               </a:ext>
             </a:extLst>
           </p:cNvPr>
@@ -2635,7 +2635,7 @@
           <p:cNvPr id="7" name="">
             <a:extLst xmlns:a="http://schemas.openxmlformats.org/drawingml/2006/main">
               <a:ext uri="{FF2B5EF4-FFF2-40B4-BE49-F238E27FC236}">
-                <a16:creationId xmlns:a16="http://schemas.microsoft.com/office/drawing/2014/main" id="{02AF9FC6-B85A-4C5C-9688-038C0D48B62E}"/>
+                <a16:creationId xmlns:a16="http://schemas.microsoft.com/office/drawing/2014/main" id="{E0A99C8F-010E-46D1-B813-52A5BCEFF476}"/>
               </a:ext>
             </a:extLst>
           </p:cNvPr>
@@ -2685,7 +2685,7 @@
           <p:cNvPr id="8" name="">
             <a:extLst xmlns:a="http://schemas.openxmlformats.org/drawingml/2006/main">
               <a:ext uri="{FF2B5EF4-FFF2-40B4-BE49-F238E27FC236}">
-                <a16:creationId xmlns:a16="http://schemas.microsoft.com/office/drawing/2014/main" id="{D164C072-7146-4E61-AFE2-71E20A5EB62B}"/>
+                <a16:creationId xmlns:a16="http://schemas.microsoft.com/office/drawing/2014/main" id="{9B896492-CCCB-4628-83A9-D464F770C91D}"/>
               </a:ext>
             </a:extLst>
           </p:cNvPr>
@@ -2720,7 +2720,7 @@
           <p:cNvPr id="9" name="">
             <a:extLst xmlns:a="http://schemas.openxmlformats.org/drawingml/2006/main">
               <a:ext uri="{FF2B5EF4-FFF2-40B4-BE49-F238E27FC236}">
-                <a16:creationId xmlns:a16="http://schemas.microsoft.com/office/drawing/2014/main" id="{2785C535-8878-41C6-8FD5-F811D041636C}"/>
+                <a16:creationId xmlns:a16="http://schemas.microsoft.com/office/drawing/2014/main" id="{59BAE44E-E5D5-4753-8A38-1F333278395C}"/>
               </a:ext>
             </a:extLst>
           </p:cNvPr>
@@ -2770,7 +2770,7 @@
           <p:cNvPr id="10" name="">
             <a:extLst xmlns:a="http://schemas.openxmlformats.org/drawingml/2006/main">
               <a:ext uri="{FF2B5EF4-FFF2-40B4-BE49-F238E27FC236}">
-                <a16:creationId xmlns:a16="http://schemas.microsoft.com/office/drawing/2014/main" id="{760ED791-9654-4AD9-86BC-B2B28E815B28}"/>
+                <a16:creationId xmlns:a16="http://schemas.microsoft.com/office/drawing/2014/main" id="{89033789-010B-430E-A5F8-868E00235FDB}"/>
               </a:ext>
             </a:extLst>
           </p:cNvPr>
@@ -2820,7 +2820,7 @@
           <p:cNvPr id="11" name="">
             <a:extLst xmlns:a="http://schemas.openxmlformats.org/drawingml/2006/main">
               <a:ext uri="{FF2B5EF4-FFF2-40B4-BE49-F238E27FC236}">
-                <a16:creationId xmlns:a16="http://schemas.microsoft.com/office/drawing/2014/main" id="{814DECBD-5BD7-4749-B853-B55808369DDA}"/>
+                <a16:creationId xmlns:a16="http://schemas.microsoft.com/office/drawing/2014/main" id="{2EAE3292-36D1-4A5D-834E-00D6BA0D5F19}"/>
               </a:ext>
             </a:extLst>
           </p:cNvPr>
@@ -2855,7 +2855,7 @@
           <p:cNvPr id="12" name="">
             <a:extLst xmlns:a="http://schemas.openxmlformats.org/drawingml/2006/main">
               <a:ext uri="{FF2B5EF4-FFF2-40B4-BE49-F238E27FC236}">
-                <a16:creationId xmlns:a16="http://schemas.microsoft.com/office/drawing/2014/main" id="{9EA52104-EF69-40A3-A390-F5D8076501EA}"/>
+                <a16:creationId xmlns:a16="http://schemas.microsoft.com/office/drawing/2014/main" id="{CA231F74-E5F3-4CEC-B869-F09552AC8B29}"/>
               </a:ext>
             </a:extLst>
           </p:cNvPr>
@@ -2905,7 +2905,7 @@
           <p:cNvPr id="13" name="">
             <a:extLst xmlns:a="http://schemas.openxmlformats.org/drawingml/2006/main">
               <a:ext uri="{FF2B5EF4-FFF2-40B4-BE49-F238E27FC236}">
-                <a16:creationId xmlns:a16="http://schemas.microsoft.com/office/drawing/2014/main" id="{7A87F661-4174-4433-8C4A-769D9D36902F}"/>
+                <a16:creationId xmlns:a16="http://schemas.microsoft.com/office/drawing/2014/main" id="{1DF1FE88-847A-4ADA-94DB-D7630B05AEB9}"/>
               </a:ext>
             </a:extLst>
           </p:cNvPr>
@@ -2955,7 +2955,7 @@
           <p:cNvPr id="14" name="">
             <a:extLst xmlns:a="http://schemas.openxmlformats.org/drawingml/2006/main">
               <a:ext uri="{FF2B5EF4-FFF2-40B4-BE49-F238E27FC236}">
-                <a16:creationId xmlns:a16="http://schemas.microsoft.com/office/drawing/2014/main" id="{A66ED2C9-4110-4ACE-A464-E3B31A7C1DBF}"/>
+                <a16:creationId xmlns:a16="http://schemas.microsoft.com/office/drawing/2014/main" id="{4ED9FC3B-6D35-4E3E-A37B-B323ADFCD2A9}"/>
               </a:ext>
             </a:extLst>
           </p:cNvPr>
@@ -2990,7 +2990,7 @@
           <p:cNvPr id="15" name="">
             <a:extLst xmlns:a="http://schemas.openxmlformats.org/drawingml/2006/main">
               <a:ext uri="{FF2B5EF4-FFF2-40B4-BE49-F238E27FC236}">
-                <a16:creationId xmlns:a16="http://schemas.microsoft.com/office/drawing/2014/main" id="{EC1734AF-F27A-4483-AD95-2411EFBB86EC}"/>
+                <a16:creationId xmlns:a16="http://schemas.microsoft.com/office/drawing/2014/main" id="{E8093ECA-C31E-41B3-BD6F-27379578CAF8}"/>
               </a:ext>
             </a:extLst>
           </p:cNvPr>
@@ -3040,7 +3040,7 @@
           <p:cNvPr id="16" name="">
             <a:extLst xmlns:a="http://schemas.openxmlformats.org/drawingml/2006/main">
               <a:ext uri="{FF2B5EF4-FFF2-40B4-BE49-F238E27FC236}">
-                <a16:creationId xmlns:a16="http://schemas.microsoft.com/office/drawing/2014/main" id="{3A9889F4-6B62-441E-B9CC-DBC62380BBFD}"/>
+                <a16:creationId xmlns:a16="http://schemas.microsoft.com/office/drawing/2014/main" id="{B885F8BA-8C9B-44F7-AA54-F91A728CEAF4}"/>
               </a:ext>
             </a:extLst>
           </p:cNvPr>
@@ -3090,7 +3090,7 @@
           <p:cNvPr id="17" name="">
             <a:extLst xmlns:a="http://schemas.openxmlformats.org/drawingml/2006/main">
               <a:ext uri="{FF2B5EF4-FFF2-40B4-BE49-F238E27FC236}">
-                <a16:creationId xmlns:a16="http://schemas.microsoft.com/office/drawing/2014/main" id="{FB12944E-8D82-4113-ADE4-3BD993E4E260}"/>
+                <a16:creationId xmlns:a16="http://schemas.microsoft.com/office/drawing/2014/main" id="{3CF1A0D2-D5DD-4DFF-A363-63C14ADB6B97}"/>
               </a:ext>
             </a:extLst>
           </p:cNvPr>
@@ -3140,7 +3140,7 @@
           <p:cNvPr id="18" name="">
             <a:extLst xmlns:a="http://schemas.openxmlformats.org/drawingml/2006/main">
               <a:ext uri="{FF2B5EF4-FFF2-40B4-BE49-F238E27FC236}">
-                <a16:creationId xmlns:a16="http://schemas.microsoft.com/office/drawing/2014/main" id="{6122C650-BC0C-4146-AE6D-3B4919F977AF}"/>
+                <a16:creationId xmlns:a16="http://schemas.microsoft.com/office/drawing/2014/main" id="{6FFF1299-75E9-487F-9400-9603C36B79A2}"/>
               </a:ext>
             </a:extLst>
           </p:cNvPr>
@@ -3190,7 +3190,7 @@
           <p:cNvPr id="19" name="">
             <a:extLst xmlns:a="http://schemas.openxmlformats.org/drawingml/2006/main">
               <a:ext uri="{FF2B5EF4-FFF2-40B4-BE49-F238E27FC236}">
-                <a16:creationId xmlns:a16="http://schemas.microsoft.com/office/drawing/2014/main" id="{27C9500B-DA71-4F7F-A28D-D46AFB9CDBFD}"/>
+                <a16:creationId xmlns:a16="http://schemas.microsoft.com/office/drawing/2014/main" id="{D389D19C-72F9-4904-B396-E7B49BAB906A}"/>
               </a:ext>
             </a:extLst>
           </p:cNvPr>
@@ -3238,7 +3238,7 @@
     </p:spTree>
     <p:extLst>
       <p:ext uri="{BB962C8B-B14F-4D97-AF65-F5344CB8AC3E}">
-        <p14:creationId xmlns:p14="http://schemas.microsoft.com/office/powerpoint/2010/main" val="2016981692"/>
+        <p14:creationId xmlns:p14="http://schemas.microsoft.com/office/powerpoint/2010/main" val="1603928324"/>
       </p:ext>
     </p:extLst>
   </p:cSld>
@@ -3269,7 +3269,7 @@
           <p:cNvPr id="1" name="">
             <a:extLst xmlns:a="http://schemas.openxmlformats.org/drawingml/2006/main">
               <a:ext uri="{FF2B5EF4-FFF2-40B4-BE49-F238E27FC236}">
-                <a16:creationId xmlns:a16="http://schemas.microsoft.com/office/drawing/2014/main" id="{0B39FB16-269A-4200-BF0A-31F2052409AC}"/>
+                <a16:creationId xmlns:a16="http://schemas.microsoft.com/office/drawing/2014/main" id="{23040B6F-A2CC-47A2-957D-2D00FE0B0BEE}"/>
               </a:ext>
             </a:extLst>
           </p:cNvPr>
@@ -3319,7 +3319,7 @@
           <p:cNvPr id="2" name="">
             <a:extLst xmlns:a="http://schemas.openxmlformats.org/drawingml/2006/main">
               <a:ext uri="{FF2B5EF4-FFF2-40B4-BE49-F238E27FC236}">
-                <a16:creationId xmlns:a16="http://schemas.microsoft.com/office/drawing/2014/main" id="{1B4BE85D-9099-47BC-B38A-0F472BB39D0B}"/>
+                <a16:creationId xmlns:a16="http://schemas.microsoft.com/office/drawing/2014/main" id="{CFC80536-0135-4583-8E60-F54BD0D3C0AF}"/>
               </a:ext>
             </a:extLst>
           </p:cNvPr>
@@ -3369,7 +3369,7 @@
           <p:cNvPr id="3" name="">
             <a:extLst xmlns:a="http://schemas.openxmlformats.org/drawingml/2006/main">
               <a:ext uri="{FF2B5EF4-FFF2-40B4-BE49-F238E27FC236}">
-                <a16:creationId xmlns:a16="http://schemas.microsoft.com/office/drawing/2014/main" id="{901AF893-0C7C-4AAF-9EEB-E1FE76F58F05}"/>
+                <a16:creationId xmlns:a16="http://schemas.microsoft.com/office/drawing/2014/main" id="{083DD11A-0FF9-4C17-855E-64434BB83576}"/>
               </a:ext>
             </a:extLst>
           </p:cNvPr>
@@ -3400,7 +3400,7 @@
           <p:cNvPr id="4" name="">
             <a:extLst xmlns:a="http://schemas.openxmlformats.org/drawingml/2006/main">
               <a:ext uri="{FF2B5EF4-FFF2-40B4-BE49-F238E27FC236}">
-                <a16:creationId xmlns:a16="http://schemas.microsoft.com/office/drawing/2014/main" id="{72B5B60D-B156-4E48-BD02-394F6ACB170B}"/>
+                <a16:creationId xmlns:a16="http://schemas.microsoft.com/office/drawing/2014/main" id="{BC035692-87A8-4457-B195-5E87812E5E50}"/>
               </a:ext>
             </a:extLst>
           </p:cNvPr>
@@ -3433,7 +3433,7 @@
           <p:cNvPr id="5" name="">
             <a:extLst xmlns:a="http://schemas.openxmlformats.org/drawingml/2006/main">
               <a:ext uri="{FF2B5EF4-FFF2-40B4-BE49-F238E27FC236}">
-                <a16:creationId xmlns:a16="http://schemas.microsoft.com/office/drawing/2014/main" id="{8D2DD7AA-A25B-4A59-A429-AA510A0F4B10}"/>
+                <a16:creationId xmlns:a16="http://schemas.microsoft.com/office/drawing/2014/main" id="{C08AE7EF-BADE-4276-BB0A-E93660CC1A53}"/>
               </a:ext>
             </a:extLst>
           </p:cNvPr>
@@ -3483,7 +3483,7 @@
           <p:cNvPr id="6" name="">
             <a:extLst xmlns:a="http://schemas.openxmlformats.org/drawingml/2006/main">
               <a:ext uri="{FF2B5EF4-FFF2-40B4-BE49-F238E27FC236}">
-                <a16:creationId xmlns:a16="http://schemas.microsoft.com/office/drawing/2014/main" id="{76FDF7CA-DCB9-46FF-A48A-A79086EDCC5D}"/>
+                <a16:creationId xmlns:a16="http://schemas.microsoft.com/office/drawing/2014/main" id="{5F2A630D-A3E5-4F27-A312-5D27AF0152BD}"/>
               </a:ext>
             </a:extLst>
           </p:cNvPr>
@@ -3599,7 +3599,7 @@
           <p:cNvPr id="7" name="">
             <a:extLst xmlns:a="http://schemas.openxmlformats.org/drawingml/2006/main">
               <a:ext uri="{FF2B5EF4-FFF2-40B4-BE49-F238E27FC236}">
-                <a16:creationId xmlns:a16="http://schemas.microsoft.com/office/drawing/2014/main" id="{7E67E408-57C5-425E-BCCD-F4468727679F}"/>
+                <a16:creationId xmlns:a16="http://schemas.microsoft.com/office/drawing/2014/main" id="{FBA57FAD-347E-4FC3-9AEA-563FEAD3B304}"/>
               </a:ext>
             </a:extLst>
           </p:cNvPr>
@@ -3649,7 +3649,7 @@
           <p:cNvPr id="8" name="">
             <a:extLst xmlns:a="http://schemas.openxmlformats.org/drawingml/2006/main">
               <a:ext uri="{FF2B5EF4-FFF2-40B4-BE49-F238E27FC236}">
-                <a16:creationId xmlns:a16="http://schemas.microsoft.com/office/drawing/2014/main" id="{473ACD0A-4690-45C8-8392-518A732B4F0E}"/>
+                <a16:creationId xmlns:a16="http://schemas.microsoft.com/office/drawing/2014/main" id="{6C01E003-E52A-4F70-87F8-8ADE814263DB}"/>
               </a:ext>
             </a:extLst>
           </p:cNvPr>
@@ -3699,7 +3699,7 @@
           <p:cNvPr id="9" name="">
             <a:extLst xmlns:a="http://schemas.openxmlformats.org/drawingml/2006/main">
               <a:ext uri="{FF2B5EF4-FFF2-40B4-BE49-F238E27FC236}">
-                <a16:creationId xmlns:a16="http://schemas.microsoft.com/office/drawing/2014/main" id="{BA624D9C-7018-4190-BF1F-6A1C2D9C3843}"/>
+                <a16:creationId xmlns:a16="http://schemas.microsoft.com/office/drawing/2014/main" id="{BB4B97C9-BEA7-476B-8F7F-CB46A2C0AEC5}"/>
               </a:ext>
             </a:extLst>
           </p:cNvPr>
@@ -3747,7 +3747,7 @@
     </p:spTree>
     <p:extLst>
       <p:ext uri="{BB962C8B-B14F-4D97-AF65-F5344CB8AC3E}">
-        <p14:creationId xmlns:p14="http://schemas.microsoft.com/office/powerpoint/2010/main" val="1390879259"/>
+        <p14:creationId xmlns:p14="http://schemas.microsoft.com/office/powerpoint/2010/main" val="1910302413"/>
       </p:ext>
     </p:extLst>
   </p:cSld>
@@ -3778,7 +3778,7 @@
           <p:cNvPr id="1" name="">
             <a:extLst xmlns:a="http://schemas.openxmlformats.org/drawingml/2006/main">
               <a:ext uri="{FF2B5EF4-FFF2-40B4-BE49-F238E27FC236}">
-                <a16:creationId xmlns:a16="http://schemas.microsoft.com/office/drawing/2014/main" id="{ADB4251C-9D8F-428B-AD20-E1D33A389252}"/>
+                <a16:creationId xmlns:a16="http://schemas.microsoft.com/office/drawing/2014/main" id="{91D202E2-104F-438F-80A5-A9A02D77492D}"/>
               </a:ext>
             </a:extLst>
           </p:cNvPr>
@@ -3828,7 +3828,7 @@
           <p:cNvPr id="2" name="">
             <a:extLst xmlns:a="http://schemas.openxmlformats.org/drawingml/2006/main">
               <a:ext uri="{FF2B5EF4-FFF2-40B4-BE49-F238E27FC236}">
-                <a16:creationId xmlns:a16="http://schemas.microsoft.com/office/drawing/2014/main" id="{C9D16520-6714-4A09-9125-31157458F3B7}"/>
+                <a16:creationId xmlns:a16="http://schemas.microsoft.com/office/drawing/2014/main" id="{30F106B5-BAF6-49A7-88D9-9040D548DA12}"/>
               </a:ext>
             </a:extLst>
           </p:cNvPr>
@@ -3895,7 +3895,7 @@
           <p:cNvPr id="3" name="">
             <a:extLst xmlns:a="http://schemas.openxmlformats.org/drawingml/2006/main">
               <a:ext uri="{FF2B5EF4-FFF2-40B4-BE49-F238E27FC236}">
-                <a16:creationId xmlns:a16="http://schemas.microsoft.com/office/drawing/2014/main" id="{C603692E-3636-43B8-ABFE-A4E0B8A733AF}"/>
+                <a16:creationId xmlns:a16="http://schemas.microsoft.com/office/drawing/2014/main" id="{8A340984-F272-48F4-8B6C-222D76BA8F27}"/>
               </a:ext>
             </a:extLst>
           </p:cNvPr>
@@ -3926,7 +3926,7 @@
           <p:cNvPr id="4" name="">
             <a:extLst xmlns:a="http://schemas.openxmlformats.org/drawingml/2006/main">
               <a:ext uri="{FF2B5EF4-FFF2-40B4-BE49-F238E27FC236}">
-                <a16:creationId xmlns:a16="http://schemas.microsoft.com/office/drawing/2014/main" id="{309B1EB2-7DD8-4C08-8DD6-B388468EA40A}"/>
+                <a16:creationId xmlns:a16="http://schemas.microsoft.com/office/drawing/2014/main" id="{A1D3DB66-87AD-41F1-B9B1-E87C87A962FF}"/>
               </a:ext>
             </a:extLst>
           </p:cNvPr>
@@ -3976,7 +3976,7 @@
           <p:cNvPr id="5" name="">
             <a:extLst xmlns:a="http://schemas.openxmlformats.org/drawingml/2006/main">
               <a:ext uri="{FF2B5EF4-FFF2-40B4-BE49-F238E27FC236}">
-                <a16:creationId xmlns:a16="http://schemas.microsoft.com/office/drawing/2014/main" id="{F003850F-DC06-46C1-8610-9124F53AEE89}"/>
+                <a16:creationId xmlns:a16="http://schemas.microsoft.com/office/drawing/2014/main" id="{7E4CABEF-93B8-4F83-8A6C-DFC33A28D56A}"/>
               </a:ext>
             </a:extLst>
           </p:cNvPr>
@@ -4026,7 +4026,7 @@
           <p:cNvPr id="6" name="">
             <a:extLst xmlns:a="http://schemas.openxmlformats.org/drawingml/2006/main">
               <a:ext uri="{FF2B5EF4-FFF2-40B4-BE49-F238E27FC236}">
-                <a16:creationId xmlns:a16="http://schemas.microsoft.com/office/drawing/2014/main" id="{4184D5F4-E394-4014-9329-9D85DB32185E}"/>
+                <a16:creationId xmlns:a16="http://schemas.microsoft.com/office/drawing/2014/main" id="{FCE231F4-331E-40D7-9976-95DDC58FFAE1}"/>
               </a:ext>
             </a:extLst>
           </p:cNvPr>
@@ -4076,7 +4076,7 @@
           <p:cNvPr id="7" name="">
             <a:extLst xmlns:a="http://schemas.openxmlformats.org/drawingml/2006/main">
               <a:ext uri="{FF2B5EF4-FFF2-40B4-BE49-F238E27FC236}">
-                <a16:creationId xmlns:a16="http://schemas.microsoft.com/office/drawing/2014/main" id="{C8E02EAB-37C4-4749-B33C-F80A6FDFF01C}"/>
+                <a16:creationId xmlns:a16="http://schemas.microsoft.com/office/drawing/2014/main" id="{64F5D46E-6DE2-4BD8-A968-18D245740467}"/>
               </a:ext>
             </a:extLst>
           </p:cNvPr>
@@ -4126,7 +4126,7 @@
           <p:cNvPr id="8" name="">
             <a:extLst xmlns:a="http://schemas.openxmlformats.org/drawingml/2006/main">
               <a:ext uri="{FF2B5EF4-FFF2-40B4-BE49-F238E27FC236}">
-                <a16:creationId xmlns:a16="http://schemas.microsoft.com/office/drawing/2014/main" id="{6660EA99-EB4D-4DC4-9406-6211E10AE9B2}"/>
+                <a16:creationId xmlns:a16="http://schemas.microsoft.com/office/drawing/2014/main" id="{B465F4F4-E756-4B01-95B4-6B22180EC05A}"/>
               </a:ext>
             </a:extLst>
           </p:cNvPr>
@@ -4174,7 +4174,7 @@
     </p:spTree>
     <p:extLst>
       <p:ext uri="{BB962C8B-B14F-4D97-AF65-F5344CB8AC3E}">
-        <p14:creationId xmlns:p14="http://schemas.microsoft.com/office/powerpoint/2010/main" val="1565597934"/>
+        <p14:creationId xmlns:p14="http://schemas.microsoft.com/office/powerpoint/2010/main" val="1756352653"/>
       </p:ext>
     </p:extLst>
   </p:cSld>
@@ -4205,7 +4205,7 @@
           <p:cNvPr id="1" name="">
             <a:extLst xmlns:a="http://schemas.openxmlformats.org/drawingml/2006/main">
               <a:ext uri="{FF2B5EF4-FFF2-40B4-BE49-F238E27FC236}">
-                <a16:creationId xmlns:a16="http://schemas.microsoft.com/office/drawing/2014/main" id="{A9C16687-FB69-4DAE-A145-B2A897316B16}"/>
+                <a16:creationId xmlns:a16="http://schemas.microsoft.com/office/drawing/2014/main" id="{2750E3A8-BFA7-449F-B0DF-7C3529A27A85}"/>
               </a:ext>
             </a:extLst>
           </p:cNvPr>
@@ -4255,7 +4255,7 @@
           <p:cNvPr id="2" name="">
             <a:extLst xmlns:a="http://schemas.openxmlformats.org/drawingml/2006/main">
               <a:ext uri="{FF2B5EF4-FFF2-40B4-BE49-F238E27FC236}">
-                <a16:creationId xmlns:a16="http://schemas.microsoft.com/office/drawing/2014/main" id="{5D1BDD6B-4E6D-4422-B724-82D59077CD73}"/>
+                <a16:creationId xmlns:a16="http://schemas.microsoft.com/office/drawing/2014/main" id="{028DC2A9-4461-4B3F-B863-6C1D9C15F31E}"/>
               </a:ext>
             </a:extLst>
           </p:cNvPr>
@@ -4305,7 +4305,7 @@
           <p:cNvPr id="3" name="">
             <a:extLst xmlns:a="http://schemas.openxmlformats.org/drawingml/2006/main">
               <a:ext uri="{FF2B5EF4-FFF2-40B4-BE49-F238E27FC236}">
-                <a16:creationId xmlns:a16="http://schemas.microsoft.com/office/drawing/2014/main" id="{399EA7F6-0967-40DB-909B-0E451BBB4E43}"/>
+                <a16:creationId xmlns:a16="http://schemas.microsoft.com/office/drawing/2014/main" id="{E7C6BDF2-C538-4359-865F-E3148BF60BD3}"/>
               </a:ext>
             </a:extLst>
           </p:cNvPr>
@@ -4336,7 +4336,7 @@
           <p:cNvPr id="4" name="">
             <a:extLst xmlns:a="http://schemas.openxmlformats.org/drawingml/2006/main">
               <a:ext uri="{FF2B5EF4-FFF2-40B4-BE49-F238E27FC236}">
-                <a16:creationId xmlns:a16="http://schemas.microsoft.com/office/drawing/2014/main" id="{9AA1B4A6-AA01-4829-BC03-01AB0D5650B4}"/>
+                <a16:creationId xmlns:a16="http://schemas.microsoft.com/office/drawing/2014/main" id="{2024397C-389A-4035-8661-2CE7C75106DF}"/>
               </a:ext>
             </a:extLst>
           </p:cNvPr>
@@ -4386,7 +4386,7 @@
           <p:cNvPr id="5" name="">
             <a:extLst xmlns:a="http://schemas.openxmlformats.org/drawingml/2006/main">
               <a:ext uri="{FF2B5EF4-FFF2-40B4-BE49-F238E27FC236}">
-                <a16:creationId xmlns:a16="http://schemas.microsoft.com/office/drawing/2014/main" id="{679C42A0-F5A2-4408-A982-842C12FB17E9}"/>
+                <a16:creationId xmlns:a16="http://schemas.microsoft.com/office/drawing/2014/main" id="{1A5A74DD-4576-4272-9B99-67EEFFACB99B}"/>
               </a:ext>
             </a:extLst>
           </p:cNvPr>
@@ -4487,7 +4487,7 @@
           <p:cNvPr id="6" name="">
             <a:extLst xmlns:a="http://schemas.openxmlformats.org/drawingml/2006/main">
               <a:ext uri="{FF2B5EF4-FFF2-40B4-BE49-F238E27FC236}">
-                <a16:creationId xmlns:a16="http://schemas.microsoft.com/office/drawing/2014/main" id="{A8C5F0D6-113E-4A65-930A-B9BE0FCB88FB}"/>
+                <a16:creationId xmlns:a16="http://schemas.microsoft.com/office/drawing/2014/main" id="{60504F56-A91D-437D-95B8-1CD24FBC5D93}"/>
               </a:ext>
             </a:extLst>
           </p:cNvPr>
@@ -4520,7 +4520,7 @@
           <p:cNvPr id="7" name="">
             <a:extLst xmlns:a="http://schemas.openxmlformats.org/drawingml/2006/main">
               <a:ext uri="{FF2B5EF4-FFF2-40B4-BE49-F238E27FC236}">
-                <a16:creationId xmlns:a16="http://schemas.microsoft.com/office/drawing/2014/main" id="{AA373CCC-120E-4A80-A8C7-3A3499433062}"/>
+                <a16:creationId xmlns:a16="http://schemas.microsoft.com/office/drawing/2014/main" id="{7ABE961D-D8AF-4C71-B0DF-F9737820C07A}"/>
               </a:ext>
             </a:extLst>
           </p:cNvPr>
@@ -4570,7 +4570,7 @@
           <p:cNvPr id="8" name="">
             <a:extLst xmlns:a="http://schemas.openxmlformats.org/drawingml/2006/main">
               <a:ext uri="{FF2B5EF4-FFF2-40B4-BE49-F238E27FC236}">
-                <a16:creationId xmlns:a16="http://schemas.microsoft.com/office/drawing/2014/main" id="{5F1451A1-08AA-4DF2-A50F-30547D3B87D1}"/>
+                <a16:creationId xmlns:a16="http://schemas.microsoft.com/office/drawing/2014/main" id="{E46A4F8B-E277-4DE6-B575-40C773E2310E}"/>
               </a:ext>
             </a:extLst>
           </p:cNvPr>
@@ -4620,7 +4620,7 @@
           <p:cNvPr id="9" name="">
             <a:extLst xmlns:a="http://schemas.openxmlformats.org/drawingml/2006/main">
               <a:ext uri="{FF2B5EF4-FFF2-40B4-BE49-F238E27FC236}">
-                <a16:creationId xmlns:a16="http://schemas.microsoft.com/office/drawing/2014/main" id="{41E42962-4B7C-4E29-8AB7-004C2FFFA157}"/>
+                <a16:creationId xmlns:a16="http://schemas.microsoft.com/office/drawing/2014/main" id="{1D3B0F3B-5D83-443D-B8A0-4325E592EC30}"/>
               </a:ext>
             </a:extLst>
           </p:cNvPr>
@@ -4670,7 +4670,7 @@
           <p:cNvPr id="10" name="">
             <a:extLst xmlns:a="http://schemas.openxmlformats.org/drawingml/2006/main">
               <a:ext uri="{FF2B5EF4-FFF2-40B4-BE49-F238E27FC236}">
-                <a16:creationId xmlns:a16="http://schemas.microsoft.com/office/drawing/2014/main" id="{954FC406-FAD6-4EFB-A23A-87A398D1E11A}"/>
+                <a16:creationId xmlns:a16="http://schemas.microsoft.com/office/drawing/2014/main" id="{296595BA-F882-4F98-98FA-70F6D59B11C1}"/>
               </a:ext>
             </a:extLst>
           </p:cNvPr>
@@ -4718,7 +4718,7 @@
     </p:spTree>
     <p:extLst>
       <p:ext uri="{BB962C8B-B14F-4D97-AF65-F5344CB8AC3E}">
-        <p14:creationId xmlns:p14="http://schemas.microsoft.com/office/powerpoint/2010/main" val="657216466"/>
+        <p14:creationId xmlns:p14="http://schemas.microsoft.com/office/powerpoint/2010/main" val="1179205141"/>
       </p:ext>
     </p:extLst>
   </p:cSld>
@@ -4749,7 +4749,7 @@
           <p:cNvPr id="1" name="">
             <a:extLst xmlns:a="http://schemas.openxmlformats.org/drawingml/2006/main">
               <a:ext uri="{FF2B5EF4-FFF2-40B4-BE49-F238E27FC236}">
-                <a16:creationId xmlns:a16="http://schemas.microsoft.com/office/drawing/2014/main" id="{57737AAB-51D1-4A43-9DFB-C1C53413F898}"/>
+                <a16:creationId xmlns:a16="http://schemas.microsoft.com/office/drawing/2014/main" id="{C53C6B1D-BBC4-4729-BED6-7ACCE359E4F2}"/>
               </a:ext>
             </a:extLst>
           </p:cNvPr>
@@ -4799,7 +4799,7 @@
           <p:cNvPr id="2" name="">
             <a:extLst xmlns:a="http://schemas.openxmlformats.org/drawingml/2006/main">
               <a:ext uri="{FF2B5EF4-FFF2-40B4-BE49-F238E27FC236}">
-                <a16:creationId xmlns:a16="http://schemas.microsoft.com/office/drawing/2014/main" id="{FE00C7B1-38D9-4A02-B1D8-F096F3A9C769}"/>
+                <a16:creationId xmlns:a16="http://schemas.microsoft.com/office/drawing/2014/main" id="{279A4704-D3BE-4297-8063-907D2AA9AEA1}"/>
               </a:ext>
             </a:extLst>
           </p:cNvPr>
@@ -4849,7 +4849,7 @@
           <p:cNvPr id="3" name="">
             <a:extLst xmlns:a="http://schemas.openxmlformats.org/drawingml/2006/main">
               <a:ext uri="{FF2B5EF4-FFF2-40B4-BE49-F238E27FC236}">
-                <a16:creationId xmlns:a16="http://schemas.microsoft.com/office/drawing/2014/main" id="{4BF022D9-64C2-47D1-A5E3-0AE988D788F5}"/>
+                <a16:creationId xmlns:a16="http://schemas.microsoft.com/office/drawing/2014/main" id="{E784E1F9-28C3-485B-ADCD-E70F6B27339C}"/>
               </a:ext>
             </a:extLst>
           </p:cNvPr>
@@ -4880,7 +4880,7 @@
           <p:cNvPr id="4" name="">
             <a:extLst xmlns:a="http://schemas.openxmlformats.org/drawingml/2006/main">
               <a:ext uri="{FF2B5EF4-FFF2-40B4-BE49-F238E27FC236}">
-                <a16:creationId xmlns:a16="http://schemas.microsoft.com/office/drawing/2014/main" id="{F4B8E4B9-ABB3-4A80-83DF-AE58BF62A449}"/>
+                <a16:creationId xmlns:a16="http://schemas.microsoft.com/office/drawing/2014/main" id="{5B9555DF-4C7F-46A6-8BE1-CA815E3B982A}"/>
               </a:ext>
             </a:extLst>
           </p:cNvPr>
@@ -4930,7 +4930,7 @@
           <p:cNvPr id="5" name="">
             <a:extLst xmlns:a="http://schemas.openxmlformats.org/drawingml/2006/main">
               <a:ext uri="{FF2B5EF4-FFF2-40B4-BE49-F238E27FC236}">
-                <a16:creationId xmlns:a16="http://schemas.microsoft.com/office/drawing/2014/main" id="{D2D3C10B-DCE6-4392-A673-A80174FAC75A}"/>
+                <a16:creationId xmlns:a16="http://schemas.microsoft.com/office/drawing/2014/main" id="{B58DAA05-BB59-4E02-96C6-31A42A5D5D6E}"/>
               </a:ext>
             </a:extLst>
           </p:cNvPr>
@@ -4963,7 +4963,7 @@
           <p:cNvPr id="6" name="">
             <a:extLst xmlns:a="http://schemas.openxmlformats.org/drawingml/2006/main">
               <a:ext uri="{FF2B5EF4-FFF2-40B4-BE49-F238E27FC236}">
-                <a16:creationId xmlns:a16="http://schemas.microsoft.com/office/drawing/2014/main" id="{8003C48B-149D-4151-8833-1DE38CE5F850}"/>
+                <a16:creationId xmlns:a16="http://schemas.microsoft.com/office/drawing/2014/main" id="{4F5BDD23-B6AA-4A6D-90B6-3951CAD14117}"/>
               </a:ext>
             </a:extLst>
           </p:cNvPr>
@@ -5013,7 +5013,7 @@
           <p:cNvPr id="7" name="">
             <a:extLst xmlns:a="http://schemas.openxmlformats.org/drawingml/2006/main">
               <a:ext uri="{FF2B5EF4-FFF2-40B4-BE49-F238E27FC236}">
-                <a16:creationId xmlns:a16="http://schemas.microsoft.com/office/drawing/2014/main" id="{BEA73213-D7A6-4CA3-BF95-030B1D5367B7}"/>
+                <a16:creationId xmlns:a16="http://schemas.microsoft.com/office/drawing/2014/main" id="{D66AD7DF-3075-4264-96E9-649081C0432E}"/>
               </a:ext>
             </a:extLst>
           </p:cNvPr>
@@ -5063,7 +5063,7 @@
           <p:cNvPr id="8" name="">
             <a:extLst xmlns:a="http://schemas.openxmlformats.org/drawingml/2006/main">
               <a:ext uri="{FF2B5EF4-FFF2-40B4-BE49-F238E27FC236}">
-                <a16:creationId xmlns:a16="http://schemas.microsoft.com/office/drawing/2014/main" id="{BAB93A63-0CC1-40BD-9616-7039D155FAE0}"/>
+                <a16:creationId xmlns:a16="http://schemas.microsoft.com/office/drawing/2014/main" id="{E01C19E5-A0EA-40ED-9BA3-DB78845F81BE}"/>
               </a:ext>
             </a:extLst>
           </p:cNvPr>
@@ -5113,7 +5113,7 @@
           <p:cNvPr id="9" name="">
             <a:extLst xmlns:a="http://schemas.openxmlformats.org/drawingml/2006/main">
               <a:ext uri="{FF2B5EF4-FFF2-40B4-BE49-F238E27FC236}">
-                <a16:creationId xmlns:a16="http://schemas.microsoft.com/office/drawing/2014/main" id="{21974F4C-E302-4ED7-B6C0-224308475C6B}"/>
+                <a16:creationId xmlns:a16="http://schemas.microsoft.com/office/drawing/2014/main" id="{D725EED0-4459-4DD7-AF87-503925404633}"/>
               </a:ext>
             </a:extLst>
           </p:cNvPr>
@@ -5146,7 +5146,7 @@
           <p:cNvPr id="10" name="">
             <a:extLst xmlns:a="http://schemas.openxmlformats.org/drawingml/2006/main">
               <a:ext uri="{FF2B5EF4-FFF2-40B4-BE49-F238E27FC236}">
-                <a16:creationId xmlns:a16="http://schemas.microsoft.com/office/drawing/2014/main" id="{DB921A10-AF21-48BB-BA3C-6D2D248BDC42}"/>
+                <a16:creationId xmlns:a16="http://schemas.microsoft.com/office/drawing/2014/main" id="{F9471FF0-F93D-4E3E-8D20-5F0C8CD61DBA}"/>
               </a:ext>
             </a:extLst>
           </p:cNvPr>
@@ -5196,7 +5196,7 @@
           <p:cNvPr id="11" name="">
             <a:extLst xmlns:a="http://schemas.openxmlformats.org/drawingml/2006/main">
               <a:ext uri="{FF2B5EF4-FFF2-40B4-BE49-F238E27FC236}">
-                <a16:creationId xmlns:a16="http://schemas.microsoft.com/office/drawing/2014/main" id="{7516B3F8-5999-4AEC-820F-03BE37ECD563}"/>
+                <a16:creationId xmlns:a16="http://schemas.microsoft.com/office/drawing/2014/main" id="{2078BF15-4AA4-41CB-9D44-3BBA7A378688}"/>
               </a:ext>
             </a:extLst>
           </p:cNvPr>
@@ -5246,7 +5246,7 @@
           <p:cNvPr id="12" name="">
             <a:extLst xmlns:a="http://schemas.openxmlformats.org/drawingml/2006/main">
               <a:ext uri="{FF2B5EF4-FFF2-40B4-BE49-F238E27FC236}">
-                <a16:creationId xmlns:a16="http://schemas.microsoft.com/office/drawing/2014/main" id="{7B49E14D-CF08-41D9-AD4B-3957189FB11C}"/>
+                <a16:creationId xmlns:a16="http://schemas.microsoft.com/office/drawing/2014/main" id="{1880559B-37A1-4B32-94F1-F8FD8A1CB2B2}"/>
               </a:ext>
             </a:extLst>
           </p:cNvPr>
@@ -5296,7 +5296,7 @@
           <p:cNvPr id="13" name="">
             <a:extLst xmlns:a="http://schemas.openxmlformats.org/drawingml/2006/main">
               <a:ext uri="{FF2B5EF4-FFF2-40B4-BE49-F238E27FC236}">
-                <a16:creationId xmlns:a16="http://schemas.microsoft.com/office/drawing/2014/main" id="{0C23B8E6-D38B-48CA-86BF-6E3AE4064D51}"/>
+                <a16:creationId xmlns:a16="http://schemas.microsoft.com/office/drawing/2014/main" id="{F345246E-0ACD-4BCC-B907-313BE5C96907}"/>
               </a:ext>
             </a:extLst>
           </p:cNvPr>
@@ -5329,7 +5329,7 @@
           <p:cNvPr id="14" name="">
             <a:extLst xmlns:a="http://schemas.openxmlformats.org/drawingml/2006/main">
               <a:ext uri="{FF2B5EF4-FFF2-40B4-BE49-F238E27FC236}">
-                <a16:creationId xmlns:a16="http://schemas.microsoft.com/office/drawing/2014/main" id="{718D91C6-C98D-4D25-B49C-B63B62069EA5}"/>
+                <a16:creationId xmlns:a16="http://schemas.microsoft.com/office/drawing/2014/main" id="{3B4431BE-3D67-4969-8A7E-6409B934A7B0}"/>
               </a:ext>
             </a:extLst>
           </p:cNvPr>
@@ -5379,7 +5379,7 @@
           <p:cNvPr id="15" name="">
             <a:extLst xmlns:a="http://schemas.openxmlformats.org/drawingml/2006/main">
               <a:ext uri="{FF2B5EF4-FFF2-40B4-BE49-F238E27FC236}">
-                <a16:creationId xmlns:a16="http://schemas.microsoft.com/office/drawing/2014/main" id="{EDEE6247-CD84-430A-8348-47314BB1CF01}"/>
+                <a16:creationId xmlns:a16="http://schemas.microsoft.com/office/drawing/2014/main" id="{432AF55F-EDB3-4BD5-8DED-0085061EA166}"/>
               </a:ext>
             </a:extLst>
           </p:cNvPr>
@@ -5429,7 +5429,7 @@
           <p:cNvPr id="16" name="">
             <a:extLst xmlns:a="http://schemas.openxmlformats.org/drawingml/2006/main">
               <a:ext uri="{FF2B5EF4-FFF2-40B4-BE49-F238E27FC236}">
-                <a16:creationId xmlns:a16="http://schemas.microsoft.com/office/drawing/2014/main" id="{326CF8D1-AE30-4B61-B27E-1BB050DF442E}"/>
+                <a16:creationId xmlns:a16="http://schemas.microsoft.com/office/drawing/2014/main" id="{43FFFD26-B02F-4C52-8CB8-B63B3E3DF4E2}"/>
               </a:ext>
             </a:extLst>
           </p:cNvPr>
@@ -5479,7 +5479,7 @@
           <p:cNvPr id="17" name="">
             <a:extLst xmlns:a="http://schemas.openxmlformats.org/drawingml/2006/main">
               <a:ext uri="{FF2B5EF4-FFF2-40B4-BE49-F238E27FC236}">
-                <a16:creationId xmlns:a16="http://schemas.microsoft.com/office/drawing/2014/main" id="{CBBAC1A8-1C0C-49F6-8E16-AEC0B02B8F0E}"/>
+                <a16:creationId xmlns:a16="http://schemas.microsoft.com/office/drawing/2014/main" id="{AFFB39D3-2AC5-46FA-B156-7503C9887BF5}"/>
               </a:ext>
             </a:extLst>
           </p:cNvPr>
@@ -5512,7 +5512,7 @@
           <p:cNvPr id="18" name="">
             <a:extLst xmlns:a="http://schemas.openxmlformats.org/drawingml/2006/main">
               <a:ext uri="{FF2B5EF4-FFF2-40B4-BE49-F238E27FC236}">
-                <a16:creationId xmlns:a16="http://schemas.microsoft.com/office/drawing/2014/main" id="{AF40C576-5F2E-49B3-A66E-EFBBC4B67B96}"/>
+                <a16:creationId xmlns:a16="http://schemas.microsoft.com/office/drawing/2014/main" id="{17A3829D-FFAE-4254-9FE8-727EEE13180D}"/>
               </a:ext>
             </a:extLst>
           </p:cNvPr>
@@ -5562,7 +5562,7 @@
           <p:cNvPr id="19" name="">
             <a:extLst xmlns:a="http://schemas.openxmlformats.org/drawingml/2006/main">
               <a:ext uri="{FF2B5EF4-FFF2-40B4-BE49-F238E27FC236}">
-                <a16:creationId xmlns:a16="http://schemas.microsoft.com/office/drawing/2014/main" id="{674D27E9-ACCC-4E4E-B18F-44D38130C3E1}"/>
+                <a16:creationId xmlns:a16="http://schemas.microsoft.com/office/drawing/2014/main" id="{81614DC5-1D96-4564-A7D8-945CCBA6058A}"/>
               </a:ext>
             </a:extLst>
           </p:cNvPr>
@@ -5612,7 +5612,7 @@
           <p:cNvPr id="20" name="">
             <a:extLst xmlns:a="http://schemas.openxmlformats.org/drawingml/2006/main">
               <a:ext uri="{FF2B5EF4-FFF2-40B4-BE49-F238E27FC236}">
-                <a16:creationId xmlns:a16="http://schemas.microsoft.com/office/drawing/2014/main" id="{C6E75E0F-8ADB-4F6E-8D2A-CAC73A8F0A51}"/>
+                <a16:creationId xmlns:a16="http://schemas.microsoft.com/office/drawing/2014/main" id="{DF4358F9-A80E-4AA5-9D71-47825B56B42B}"/>
               </a:ext>
             </a:extLst>
           </p:cNvPr>
@@ -5645,7 +5645,7 @@
           <p:cNvPr id="21" name="">
             <a:extLst xmlns:a="http://schemas.openxmlformats.org/drawingml/2006/main">
               <a:ext uri="{FF2B5EF4-FFF2-40B4-BE49-F238E27FC236}">
-                <a16:creationId xmlns:a16="http://schemas.microsoft.com/office/drawing/2014/main" id="{46B260EE-3A19-4B8A-9995-202A6C25D1B7}"/>
+                <a16:creationId xmlns:a16="http://schemas.microsoft.com/office/drawing/2014/main" id="{2D0EE8BA-4F53-4C7E-A422-6DD7D74ED3A5}"/>
               </a:ext>
             </a:extLst>
           </p:cNvPr>
@@ -5695,7 +5695,7 @@
           <p:cNvPr id="22" name="">
             <a:extLst xmlns:a="http://schemas.openxmlformats.org/drawingml/2006/main">
               <a:ext uri="{FF2B5EF4-FFF2-40B4-BE49-F238E27FC236}">
-                <a16:creationId xmlns:a16="http://schemas.microsoft.com/office/drawing/2014/main" id="{0CF91DE1-C1EF-4AAF-ADBB-E2BA359BDCDC}"/>
+                <a16:creationId xmlns:a16="http://schemas.microsoft.com/office/drawing/2014/main" id="{2BA2F87E-87C4-4E3B-8DF6-C728C11BA471}"/>
               </a:ext>
             </a:extLst>
           </p:cNvPr>
@@ -5745,7 +5745,7 @@
           <p:cNvPr id="23" name="">
             <a:extLst xmlns:a="http://schemas.openxmlformats.org/drawingml/2006/main">
               <a:ext uri="{FF2B5EF4-FFF2-40B4-BE49-F238E27FC236}">
-                <a16:creationId xmlns:a16="http://schemas.microsoft.com/office/drawing/2014/main" id="{F9D99AD0-4C45-45EA-A989-2D83C8F63B0C}"/>
+                <a16:creationId xmlns:a16="http://schemas.microsoft.com/office/drawing/2014/main" id="{915DBA33-3A43-4F9D-95A0-E9A7B8BA465E}"/>
               </a:ext>
             </a:extLst>
           </p:cNvPr>
@@ -5795,7 +5795,7 @@
           <p:cNvPr id="24" name="">
             <a:extLst xmlns:a="http://schemas.openxmlformats.org/drawingml/2006/main">
               <a:ext uri="{FF2B5EF4-FFF2-40B4-BE49-F238E27FC236}">
-                <a16:creationId xmlns:a16="http://schemas.microsoft.com/office/drawing/2014/main" id="{98B26D8D-698B-4B6D-8E84-DC0188466C8A}"/>
+                <a16:creationId xmlns:a16="http://schemas.microsoft.com/office/drawing/2014/main" id="{3E0D1535-E56F-4247-A1D0-4B91CA418F4F}"/>
               </a:ext>
             </a:extLst>
           </p:cNvPr>
@@ -5845,7 +5845,7 @@
           <p:cNvPr id="25" name="">
             <a:extLst xmlns:a="http://schemas.openxmlformats.org/drawingml/2006/main">
               <a:ext uri="{FF2B5EF4-FFF2-40B4-BE49-F238E27FC236}">
-                <a16:creationId xmlns:a16="http://schemas.microsoft.com/office/drawing/2014/main" id="{AF131F02-95F8-4772-838A-D66C8E9AA2C3}"/>
+                <a16:creationId xmlns:a16="http://schemas.microsoft.com/office/drawing/2014/main" id="{355E9994-CD48-40AF-AB06-D42D8DB8ACD7}"/>
               </a:ext>
             </a:extLst>
           </p:cNvPr>
@@ -5893,7 +5893,7 @@
     </p:spTree>
     <p:extLst>
       <p:ext uri="{BB962C8B-B14F-4D97-AF65-F5344CB8AC3E}">
-        <p14:creationId xmlns:p14="http://schemas.microsoft.com/office/powerpoint/2010/main" val="46438733"/>
+        <p14:creationId xmlns:p14="http://schemas.microsoft.com/office/powerpoint/2010/main" val="960735126"/>
       </p:ext>
     </p:extLst>
   </p:cSld>
@@ -5924,7 +5924,7 @@
           <p:cNvPr id="1" name="">
             <a:extLst xmlns:a="http://schemas.openxmlformats.org/drawingml/2006/main">
               <a:ext uri="{FF2B5EF4-FFF2-40B4-BE49-F238E27FC236}">
-                <a16:creationId xmlns:a16="http://schemas.microsoft.com/office/drawing/2014/main" id="{8FAA8A0B-C1E8-4500-B984-10091CAC6C40}"/>
+                <a16:creationId xmlns:a16="http://schemas.microsoft.com/office/drawing/2014/main" id="{396D12EC-C0A1-45C3-B275-CD8DECC00552}"/>
               </a:ext>
             </a:extLst>
           </p:cNvPr>
@@ -5974,7 +5974,7 @@
           <p:cNvPr id="2" name="">
             <a:extLst xmlns:a="http://schemas.openxmlformats.org/drawingml/2006/main">
               <a:ext uri="{FF2B5EF4-FFF2-40B4-BE49-F238E27FC236}">
-                <a16:creationId xmlns:a16="http://schemas.microsoft.com/office/drawing/2014/main" id="{F78C6190-CD88-4F88-B967-1FFAA7FF12A8}"/>
+                <a16:creationId xmlns:a16="http://schemas.microsoft.com/office/drawing/2014/main" id="{B176D71C-BB2B-4019-810A-016FA4ADEA6B}"/>
               </a:ext>
             </a:extLst>
           </p:cNvPr>
@@ -6024,7 +6024,7 @@
           <p:cNvPr id="3" name="">
             <a:extLst xmlns:a="http://schemas.openxmlformats.org/drawingml/2006/main">
               <a:ext uri="{FF2B5EF4-FFF2-40B4-BE49-F238E27FC236}">
-                <a16:creationId xmlns:a16="http://schemas.microsoft.com/office/drawing/2014/main" id="{0BB1AEAE-E869-4AB1-B009-DC149E7D7CB0}"/>
+                <a16:creationId xmlns:a16="http://schemas.microsoft.com/office/drawing/2014/main" id="{480D0302-F3BE-4AB6-8993-13F8123F492E}"/>
               </a:ext>
             </a:extLst>
           </p:cNvPr>
@@ -6055,7 +6055,7 @@
           <p:cNvPr id="4" name="">
             <a:extLst xmlns:a="http://schemas.openxmlformats.org/drawingml/2006/main">
               <a:ext uri="{FF2B5EF4-FFF2-40B4-BE49-F238E27FC236}">
-                <a16:creationId xmlns:a16="http://schemas.microsoft.com/office/drawing/2014/main" id="{38F6F988-2273-48A7-B5FF-5ADF3C578395}"/>
+                <a16:creationId xmlns:a16="http://schemas.microsoft.com/office/drawing/2014/main" id="{B72436DB-2303-471D-BFBF-CB6F18E9824F}"/>
               </a:ext>
             </a:extLst>
           </p:cNvPr>
@@ -6105,7 +6105,7 @@
           <p:cNvPr id="5" name="">
             <a:extLst xmlns:a="http://schemas.openxmlformats.org/drawingml/2006/main">
               <a:ext uri="{FF2B5EF4-FFF2-40B4-BE49-F238E27FC236}">
-                <a16:creationId xmlns:a16="http://schemas.microsoft.com/office/drawing/2014/main" id="{DFBE4642-5148-441C-B6FF-65D283F69306}"/>
+                <a16:creationId xmlns:a16="http://schemas.microsoft.com/office/drawing/2014/main" id="{F86DD27C-93FD-4A5B-8032-901014FA7A0B}"/>
               </a:ext>
             </a:extLst>
           </p:cNvPr>
@@ -6155,7 +6155,7 @@
           <p:cNvPr id="6" name="">
             <a:extLst xmlns:a="http://schemas.openxmlformats.org/drawingml/2006/main">
               <a:ext uri="{FF2B5EF4-FFF2-40B4-BE49-F238E27FC236}">
-                <a16:creationId xmlns:a16="http://schemas.microsoft.com/office/drawing/2014/main" id="{DF273CC3-59FE-4BE4-9C96-D3F1A6A9B2E3}"/>
+                <a16:creationId xmlns:a16="http://schemas.microsoft.com/office/drawing/2014/main" id="{430EF55C-1969-4D6F-9AD8-FA6FE24999E6}"/>
               </a:ext>
             </a:extLst>
           </p:cNvPr>
@@ -6205,7 +6205,7 @@
           <p:cNvPr id="7" name="">
             <a:extLst xmlns:a="http://schemas.openxmlformats.org/drawingml/2006/main">
               <a:ext uri="{FF2B5EF4-FFF2-40B4-BE49-F238E27FC236}">
-                <a16:creationId xmlns:a16="http://schemas.microsoft.com/office/drawing/2014/main" id="{BCE7D81D-B787-41E8-9273-A2ADA234A39C}"/>
+                <a16:creationId xmlns:a16="http://schemas.microsoft.com/office/drawing/2014/main" id="{35720221-C729-4ACE-B159-D0ED3A5CC85D}"/>
               </a:ext>
             </a:extLst>
           </p:cNvPr>
@@ -6253,7 +6253,7 @@
     </p:spTree>
     <p:extLst>
       <p:ext uri="{BB962C8B-B14F-4D97-AF65-F5344CB8AC3E}">
-        <p14:creationId xmlns:p14="http://schemas.microsoft.com/office/powerpoint/2010/main" val="399541092"/>
+        <p14:creationId xmlns:p14="http://schemas.microsoft.com/office/powerpoint/2010/main" val="1710867765"/>
       </p:ext>
     </p:extLst>
   </p:cSld>
@@ -6284,7 +6284,7 @@
           <p:cNvPr id="1" name="">
             <a:extLst xmlns:a="http://schemas.openxmlformats.org/drawingml/2006/main">
               <a:ext uri="{FF2B5EF4-FFF2-40B4-BE49-F238E27FC236}">
-                <a16:creationId xmlns:a16="http://schemas.microsoft.com/office/drawing/2014/main" id="{0E1A5521-9691-4245-BEEA-B98F9A1B279D}"/>
+                <a16:creationId xmlns:a16="http://schemas.microsoft.com/office/drawing/2014/main" id="{B222400A-6EE5-429C-966E-977E4E6104B9}"/>
               </a:ext>
             </a:extLst>
           </p:cNvPr>
@@ -6334,7 +6334,7 @@
           <p:cNvPr id="2" name="">
             <a:extLst xmlns:a="http://schemas.openxmlformats.org/drawingml/2006/main">
               <a:ext uri="{FF2B5EF4-FFF2-40B4-BE49-F238E27FC236}">
-                <a16:creationId xmlns:a16="http://schemas.microsoft.com/office/drawing/2014/main" id="{6D76B995-BF2B-41CF-A5FC-68D6A12861B3}"/>
+                <a16:creationId xmlns:a16="http://schemas.microsoft.com/office/drawing/2014/main" id="{658233CC-F416-4761-92D5-78EE78B13B55}"/>
               </a:ext>
             </a:extLst>
           </p:cNvPr>
@@ -6384,7 +6384,7 @@
           <p:cNvPr id="3" name="">
             <a:extLst xmlns:a="http://schemas.openxmlformats.org/drawingml/2006/main">
               <a:ext uri="{FF2B5EF4-FFF2-40B4-BE49-F238E27FC236}">
-                <a16:creationId xmlns:a16="http://schemas.microsoft.com/office/drawing/2014/main" id="{1EDD7462-0DC7-4E3A-BC53-C8E80787BBDB}"/>
+                <a16:creationId xmlns:a16="http://schemas.microsoft.com/office/drawing/2014/main" id="{DF1161CF-0105-4667-97DC-220B5F8C0BBC}"/>
               </a:ext>
             </a:extLst>
           </p:cNvPr>
@@ -6415,7 +6415,7 @@
           <p:cNvPr id="4" name="">
             <a:extLst xmlns:a="http://schemas.openxmlformats.org/drawingml/2006/main">
               <a:ext uri="{FF2B5EF4-FFF2-40B4-BE49-F238E27FC236}">
-                <a16:creationId xmlns:a16="http://schemas.microsoft.com/office/drawing/2014/main" id="{A1F20930-5AFA-49C8-A821-8082DC55E8F0}"/>
+                <a16:creationId xmlns:a16="http://schemas.microsoft.com/office/drawing/2014/main" id="{AF52F6B5-3B98-4515-A69F-58774EC93DA7}"/>
               </a:ext>
             </a:extLst>
           </p:cNvPr>
@@ -6448,7 +6448,7 @@
           <p:cNvPr id="5" name="">
             <a:extLst xmlns:a="http://schemas.openxmlformats.org/drawingml/2006/main">
               <a:ext uri="{FF2B5EF4-FFF2-40B4-BE49-F238E27FC236}">
-                <a16:creationId xmlns:a16="http://schemas.microsoft.com/office/drawing/2014/main" id="{BEE3FBB1-05F1-4EF3-BD41-5F6EEF4F7A80}"/>
+                <a16:creationId xmlns:a16="http://schemas.microsoft.com/office/drawing/2014/main" id="{A04036A1-1D89-4BCF-95B1-17869C9C2BEF}"/>
               </a:ext>
             </a:extLst>
           </p:cNvPr>
@@ -6498,7 +6498,7 @@
           <p:cNvPr id="6" name="">
             <a:extLst xmlns:a="http://schemas.openxmlformats.org/drawingml/2006/main">
               <a:ext uri="{FF2B5EF4-FFF2-40B4-BE49-F238E27FC236}">
-                <a16:creationId xmlns:a16="http://schemas.microsoft.com/office/drawing/2014/main" id="{2B813EBD-8F63-40C1-A751-6ACB2E3FBE68}"/>
+                <a16:creationId xmlns:a16="http://schemas.microsoft.com/office/drawing/2014/main" id="{1F31F259-D934-411A-9380-0F29760AF645}"/>
               </a:ext>
             </a:extLst>
           </p:cNvPr>
@@ -6565,7 +6565,7 @@
           <p:cNvPr id="7" name="">
             <a:extLst xmlns:a="http://schemas.openxmlformats.org/drawingml/2006/main">
               <a:ext uri="{FF2B5EF4-FFF2-40B4-BE49-F238E27FC236}">
-                <a16:creationId xmlns:a16="http://schemas.microsoft.com/office/drawing/2014/main" id="{E0F6621F-8440-4273-BA67-BBFFA1A74F8E}"/>
+                <a16:creationId xmlns:a16="http://schemas.microsoft.com/office/drawing/2014/main" id="{25CA8037-9C9B-4D4B-B77C-D91DE4C02A69}"/>
               </a:ext>
             </a:extLst>
           </p:cNvPr>
@@ -6615,7 +6615,7 @@
           <p:cNvPr id="8" name="">
             <a:extLst xmlns:a="http://schemas.openxmlformats.org/drawingml/2006/main">
               <a:ext uri="{FF2B5EF4-FFF2-40B4-BE49-F238E27FC236}">
-                <a16:creationId xmlns:a16="http://schemas.microsoft.com/office/drawing/2014/main" id="{4111CC32-93A0-4861-9C9E-D60669403A42}"/>
+                <a16:creationId xmlns:a16="http://schemas.microsoft.com/office/drawing/2014/main" id="{2E45915C-CE6F-4147-9A67-1980F466708A}"/>
               </a:ext>
             </a:extLst>
           </p:cNvPr>
@@ -6648,7 +6648,7 @@
           <p:cNvPr id="9" name="">
             <a:extLst xmlns:a="http://schemas.openxmlformats.org/drawingml/2006/main">
               <a:ext uri="{FF2B5EF4-FFF2-40B4-BE49-F238E27FC236}">
-                <a16:creationId xmlns:a16="http://schemas.microsoft.com/office/drawing/2014/main" id="{8009E728-3D63-4A1A-95AF-7062D4627F5E}"/>
+                <a16:creationId xmlns:a16="http://schemas.microsoft.com/office/drawing/2014/main" id="{D29EF2D3-2507-48EB-8345-C2AC40A8EFC0}"/>
               </a:ext>
             </a:extLst>
           </p:cNvPr>
@@ -6698,7 +6698,7 @@
           <p:cNvPr id="10" name="">
             <a:extLst xmlns:a="http://schemas.openxmlformats.org/drawingml/2006/main">
               <a:ext uri="{FF2B5EF4-FFF2-40B4-BE49-F238E27FC236}">
-                <a16:creationId xmlns:a16="http://schemas.microsoft.com/office/drawing/2014/main" id="{FB22E52A-D7E6-4B5B-9D16-CF634F71E99E}"/>
+                <a16:creationId xmlns:a16="http://schemas.microsoft.com/office/drawing/2014/main" id="{314F5C05-68C6-40B1-98D5-4D078C675D2B}"/>
               </a:ext>
             </a:extLst>
           </p:cNvPr>
@@ -6765,7 +6765,7 @@
           <p:cNvPr id="11" name="">
             <a:extLst xmlns:a="http://schemas.openxmlformats.org/drawingml/2006/main">
               <a:ext uri="{FF2B5EF4-FFF2-40B4-BE49-F238E27FC236}">
-                <a16:creationId xmlns:a16="http://schemas.microsoft.com/office/drawing/2014/main" id="{FE78D5B5-C1F6-4BA4-A1E2-DDBA12F6F598}"/>
+                <a16:creationId xmlns:a16="http://schemas.microsoft.com/office/drawing/2014/main" id="{8BD3E23A-5E4F-49E9-86F5-955A14DC69B0}"/>
               </a:ext>
             </a:extLst>
           </p:cNvPr>
@@ -6815,7 +6815,7 @@
           <p:cNvPr id="12" name="">
             <a:extLst xmlns:a="http://schemas.openxmlformats.org/drawingml/2006/main">
               <a:ext uri="{FF2B5EF4-FFF2-40B4-BE49-F238E27FC236}">
-                <a16:creationId xmlns:a16="http://schemas.microsoft.com/office/drawing/2014/main" id="{F4AC71E5-BA99-4F78-866D-CBC7F0B4F4A1}"/>
+                <a16:creationId xmlns:a16="http://schemas.microsoft.com/office/drawing/2014/main" id="{FB6D0E70-836C-497C-A979-940164354D92}"/>
               </a:ext>
             </a:extLst>
           </p:cNvPr>
@@ -6865,7 +6865,7 @@
           <p:cNvPr id="13" name="">
             <a:extLst xmlns:a="http://schemas.openxmlformats.org/drawingml/2006/main">
               <a:ext uri="{FF2B5EF4-FFF2-40B4-BE49-F238E27FC236}">
-                <a16:creationId xmlns:a16="http://schemas.microsoft.com/office/drawing/2014/main" id="{52750A95-DB1E-48E8-9582-BFE217A55072}"/>
+                <a16:creationId xmlns:a16="http://schemas.microsoft.com/office/drawing/2014/main" id="{76F78AD2-3D09-4DF5-9DE4-F34B5261CF98}"/>
               </a:ext>
             </a:extLst>
           </p:cNvPr>
@@ -6913,7 +6913,7 @@
     </p:spTree>
     <p:extLst>
       <p:ext uri="{BB962C8B-B14F-4D97-AF65-F5344CB8AC3E}">
-        <p14:creationId xmlns:p14="http://schemas.microsoft.com/office/powerpoint/2010/main" val="1447062917"/>
+        <p14:creationId xmlns:p14="http://schemas.microsoft.com/office/powerpoint/2010/main" val="217827488"/>
       </p:ext>
     </p:extLst>
   </p:cSld>
@@ -6944,7 +6944,7 @@
           <p:cNvPr id="1" name="">
             <a:extLst xmlns:a="http://schemas.openxmlformats.org/drawingml/2006/main">
               <a:ext uri="{FF2B5EF4-FFF2-40B4-BE49-F238E27FC236}">
-                <a16:creationId xmlns:a16="http://schemas.microsoft.com/office/drawing/2014/main" id="{584192C6-F14F-4984-8B10-89F9B505E994}"/>
+                <a16:creationId xmlns:a16="http://schemas.microsoft.com/office/drawing/2014/main" id="{E0A76ADB-9EA7-48D8-B633-0E04BE0DE5B5}"/>
               </a:ext>
             </a:extLst>
           </p:cNvPr>
@@ -6994,7 +6994,7 @@
           <p:cNvPr id="2" name="">
             <a:extLst xmlns:a="http://schemas.openxmlformats.org/drawingml/2006/main">
               <a:ext uri="{FF2B5EF4-FFF2-40B4-BE49-F238E27FC236}">
-                <a16:creationId xmlns:a16="http://schemas.microsoft.com/office/drawing/2014/main" id="{C99B2587-06B0-4687-8B05-BF00E80215AD}"/>
+                <a16:creationId xmlns:a16="http://schemas.microsoft.com/office/drawing/2014/main" id="{C16BE07E-6D0E-45AB-9AB2-B7C1FCC68B7A}"/>
               </a:ext>
             </a:extLst>
           </p:cNvPr>
@@ -7044,7 +7044,7 @@
           <p:cNvPr id="3" name="">
             <a:extLst xmlns:a="http://schemas.openxmlformats.org/drawingml/2006/main">
               <a:ext uri="{FF2B5EF4-FFF2-40B4-BE49-F238E27FC236}">
-                <a16:creationId xmlns:a16="http://schemas.microsoft.com/office/drawing/2014/main" id="{67162155-6CCC-482F-B664-01BE1D74D254}"/>
+                <a16:creationId xmlns:a16="http://schemas.microsoft.com/office/drawing/2014/main" id="{C253FD53-FC72-4217-AC02-BFAE7D6FBF55}"/>
               </a:ext>
             </a:extLst>
           </p:cNvPr>
@@ -7079,7 +7079,7 @@
           <p:nvPr/>
         </p:nvPicPr>
         <p:blipFill>
-          <a:blip xmlns:r="http://schemas.openxmlformats.org/officeDocument/2006/relationships" xmlns:a="http://schemas.openxmlformats.org/drawingml/2006/main" r:embed="R87bf5e25992a4230"/>
+          <a:blip xmlns:r="http://schemas.openxmlformats.org/officeDocument/2006/relationships" xmlns:a="http://schemas.openxmlformats.org/drawingml/2006/main" r:embed="Reb7959ee4a134014"/>
           <a:stretch xmlns:a="http://schemas.openxmlformats.org/drawingml/2006/main"/>
         </p:blipFill>
         <p:spPr>
@@ -7097,7 +7097,7 @@
           <p:cNvPr id="5" name="">
             <a:extLst xmlns:a="http://schemas.openxmlformats.org/drawingml/2006/main">
               <a:ext uri="{FF2B5EF4-FFF2-40B4-BE49-F238E27FC236}">
-                <a16:creationId xmlns:a16="http://schemas.microsoft.com/office/drawing/2014/main" id="{195595D7-E414-4553-A0C0-F4BDA95474DC}"/>
+                <a16:creationId xmlns:a16="http://schemas.microsoft.com/office/drawing/2014/main" id="{E66670A5-33C4-417D-94B4-A8C6D6DBBBB7}"/>
               </a:ext>
             </a:extLst>
           </p:cNvPr>
@@ -7147,7 +7147,7 @@
           <p:cNvPr id="6" name="">
             <a:extLst xmlns:a="http://schemas.openxmlformats.org/drawingml/2006/main">
               <a:ext uri="{FF2B5EF4-FFF2-40B4-BE49-F238E27FC236}">
-                <a16:creationId xmlns:a16="http://schemas.microsoft.com/office/drawing/2014/main" id="{8C7B67AD-A95F-4B79-8FFC-159A8880051B}"/>
+                <a16:creationId xmlns:a16="http://schemas.microsoft.com/office/drawing/2014/main" id="{ECABD979-2987-4633-8D82-1DBB8316F2C3}"/>
               </a:ext>
             </a:extLst>
           </p:cNvPr>
@@ -7195,7 +7195,7 @@
     </p:spTree>
     <p:extLst>
       <p:ext uri="{BB962C8B-B14F-4D97-AF65-F5344CB8AC3E}">
-        <p14:creationId xmlns:p14="http://schemas.microsoft.com/office/powerpoint/2010/main" val="1961183850"/>
+        <p14:creationId xmlns:p14="http://schemas.microsoft.com/office/powerpoint/2010/main" val="1016849066"/>
       </p:ext>
     </p:extLst>
   </p:cSld>
@@ -7226,7 +7226,7 @@
           <p:cNvPr id="1" name="">
             <a:extLst xmlns:a="http://schemas.openxmlformats.org/drawingml/2006/main">
               <a:ext uri="{FF2B5EF4-FFF2-40B4-BE49-F238E27FC236}">
-                <a16:creationId xmlns:a16="http://schemas.microsoft.com/office/drawing/2014/main" id="{AAB309B2-8935-4745-9D76-2431E0628F86}"/>
+                <a16:creationId xmlns:a16="http://schemas.microsoft.com/office/drawing/2014/main" id="{DE2237CE-617A-4804-A9CD-5CDF756FEE39}"/>
               </a:ext>
             </a:extLst>
           </p:cNvPr>
@@ -7276,7 +7276,7 @@
           <p:cNvPr id="2" name="">
             <a:extLst xmlns:a="http://schemas.openxmlformats.org/drawingml/2006/main">
               <a:ext uri="{FF2B5EF4-FFF2-40B4-BE49-F238E27FC236}">
-                <a16:creationId xmlns:a16="http://schemas.microsoft.com/office/drawing/2014/main" id="{BB25B685-EBEB-4BDA-B79D-2EA7B34BF92A}"/>
+                <a16:creationId xmlns:a16="http://schemas.microsoft.com/office/drawing/2014/main" id="{C1C0796A-F420-4212-A947-7173AC5D341B}"/>
               </a:ext>
             </a:extLst>
           </p:cNvPr>
@@ -7326,7 +7326,7 @@
           <p:cNvPr id="3" name="">
             <a:extLst xmlns:a="http://schemas.openxmlformats.org/drawingml/2006/main">
               <a:ext uri="{FF2B5EF4-FFF2-40B4-BE49-F238E27FC236}">
-                <a16:creationId xmlns:a16="http://schemas.microsoft.com/office/drawing/2014/main" id="{95D436F3-153A-40CA-8552-B7D45F67CB06}"/>
+                <a16:creationId xmlns:a16="http://schemas.microsoft.com/office/drawing/2014/main" id="{76976738-C9C8-4650-A6CC-5FE1AB69CA06}"/>
               </a:ext>
             </a:extLst>
           </p:cNvPr>
@@ -7357,7 +7357,7 @@
           <p:cNvPr id="4" name="">
             <a:extLst xmlns:a="http://schemas.openxmlformats.org/drawingml/2006/main">
               <a:ext uri="{FF2B5EF4-FFF2-40B4-BE49-F238E27FC236}">
-                <a16:creationId xmlns:a16="http://schemas.microsoft.com/office/drawing/2014/main" id="{C8077963-90CB-42F8-8EFA-37072F05DA90}"/>
+                <a16:creationId xmlns:a16="http://schemas.microsoft.com/office/drawing/2014/main" id="{40F4D105-B176-4405-9DCB-D8C6FA64EEA6}"/>
               </a:ext>
             </a:extLst>
           </p:cNvPr>
@@ -7407,7 +7407,7 @@
           <p:cNvPr id="5" name="">
             <a:extLst xmlns:a="http://schemas.openxmlformats.org/drawingml/2006/main">
               <a:ext uri="{FF2B5EF4-FFF2-40B4-BE49-F238E27FC236}">
-                <a16:creationId xmlns:a16="http://schemas.microsoft.com/office/drawing/2014/main" id="{7D5D35EB-EB6E-4A69-A364-4EE3CD6EAA5B}"/>
+                <a16:creationId xmlns:a16="http://schemas.microsoft.com/office/drawing/2014/main" id="{3743B481-56F1-4070-969D-BC5D64B3E450}"/>
               </a:ext>
             </a:extLst>
           </p:cNvPr>
@@ -7440,7 +7440,7 @@
           <p:cNvPr id="6" name="">
             <a:extLst xmlns:a="http://schemas.openxmlformats.org/drawingml/2006/main">
               <a:ext uri="{FF2B5EF4-FFF2-40B4-BE49-F238E27FC236}">
-                <a16:creationId xmlns:a16="http://schemas.microsoft.com/office/drawing/2014/main" id="{17CE3AB6-258D-4E74-A9BE-1A4DA4E15195}"/>
+                <a16:creationId xmlns:a16="http://schemas.microsoft.com/office/drawing/2014/main" id="{26EBEB3F-A521-4095-A988-A28A60051D85}"/>
               </a:ext>
             </a:extLst>
           </p:cNvPr>
@@ -7490,7 +7490,7 @@
           <p:cNvPr id="7" name="">
             <a:extLst xmlns:a="http://schemas.openxmlformats.org/drawingml/2006/main">
               <a:ext uri="{FF2B5EF4-FFF2-40B4-BE49-F238E27FC236}">
-                <a16:creationId xmlns:a16="http://schemas.microsoft.com/office/drawing/2014/main" id="{FF04F9E2-CA1B-453D-A900-F895A359AC88}"/>
+                <a16:creationId xmlns:a16="http://schemas.microsoft.com/office/drawing/2014/main" id="{CF583CAF-90D0-4903-8B1C-35BEB4AB6CEB}"/>
               </a:ext>
             </a:extLst>
           </p:cNvPr>
@@ -7540,7 +7540,7 @@
           <p:cNvPr id="8" name="">
             <a:extLst xmlns:a="http://schemas.openxmlformats.org/drawingml/2006/main">
               <a:ext uri="{FF2B5EF4-FFF2-40B4-BE49-F238E27FC236}">
-                <a16:creationId xmlns:a16="http://schemas.microsoft.com/office/drawing/2014/main" id="{183BDE16-7517-4598-9219-691891EEFCC3}"/>
+                <a16:creationId xmlns:a16="http://schemas.microsoft.com/office/drawing/2014/main" id="{F18A0647-BA4B-48F3-8C99-422938825FCF}"/>
               </a:ext>
             </a:extLst>
           </p:cNvPr>
@@ -7590,7 +7590,7 @@
           <p:cNvPr id="9" name="">
             <a:extLst xmlns:a="http://schemas.openxmlformats.org/drawingml/2006/main">
               <a:ext uri="{FF2B5EF4-FFF2-40B4-BE49-F238E27FC236}">
-                <a16:creationId xmlns:a16="http://schemas.microsoft.com/office/drawing/2014/main" id="{B8E1D53D-353E-490F-8D05-7FC6317DF1CD}"/>
+                <a16:creationId xmlns:a16="http://schemas.microsoft.com/office/drawing/2014/main" id="{DA8FACBC-ADAE-4561-9B8D-5ADEA15CC486}"/>
               </a:ext>
             </a:extLst>
           </p:cNvPr>
@@ -7640,7 +7640,7 @@
           <p:cNvPr id="10" name="">
             <a:extLst xmlns:a="http://schemas.openxmlformats.org/drawingml/2006/main">
               <a:ext uri="{FF2B5EF4-FFF2-40B4-BE49-F238E27FC236}">
-                <a16:creationId xmlns:a16="http://schemas.microsoft.com/office/drawing/2014/main" id="{FFB27C56-DB19-4703-AD7C-D5BB8B78FD6C}"/>
+                <a16:creationId xmlns:a16="http://schemas.microsoft.com/office/drawing/2014/main" id="{A4FA988B-881B-4DE4-899D-23A40CBBDA83}"/>
               </a:ext>
             </a:extLst>
           </p:cNvPr>
@@ -7673,7 +7673,7 @@
           <p:cNvPr id="11" name="">
             <a:extLst xmlns:a="http://schemas.openxmlformats.org/drawingml/2006/main">
               <a:ext uri="{FF2B5EF4-FFF2-40B4-BE49-F238E27FC236}">
-                <a16:creationId xmlns:a16="http://schemas.microsoft.com/office/drawing/2014/main" id="{0E4A47C9-18C4-46CF-8E95-FB6219D32FDF}"/>
+                <a16:creationId xmlns:a16="http://schemas.microsoft.com/office/drawing/2014/main" id="{BFA9CABE-2DE1-4F38-84DD-3306E04BCB1F}"/>
               </a:ext>
             </a:extLst>
           </p:cNvPr>
@@ -7723,7 +7723,7 @@
           <p:cNvPr id="12" name="">
             <a:extLst xmlns:a="http://schemas.openxmlformats.org/drawingml/2006/main">
               <a:ext uri="{FF2B5EF4-FFF2-40B4-BE49-F238E27FC236}">
-                <a16:creationId xmlns:a16="http://schemas.microsoft.com/office/drawing/2014/main" id="{ABE69C5F-D98F-4C4B-B0C0-C7629F756BED}"/>
+                <a16:creationId xmlns:a16="http://schemas.microsoft.com/office/drawing/2014/main" id="{651475DD-22EE-49B5-BDD9-A3F1376267A9}"/>
               </a:ext>
             </a:extLst>
           </p:cNvPr>
@@ -7773,7 +7773,7 @@
           <p:cNvPr id="13" name="">
             <a:extLst xmlns:a="http://schemas.openxmlformats.org/drawingml/2006/main">
               <a:ext uri="{FF2B5EF4-FFF2-40B4-BE49-F238E27FC236}">
-                <a16:creationId xmlns:a16="http://schemas.microsoft.com/office/drawing/2014/main" id="{6C95467C-17FA-4C11-84D4-3381801A14AE}"/>
+                <a16:creationId xmlns:a16="http://schemas.microsoft.com/office/drawing/2014/main" id="{63BE847B-C857-4531-907D-E03FD29642A6}"/>
               </a:ext>
             </a:extLst>
           </p:cNvPr>
@@ -7823,7 +7823,7 @@
           <p:cNvPr id="14" name="">
             <a:extLst xmlns:a="http://schemas.openxmlformats.org/drawingml/2006/main">
               <a:ext uri="{FF2B5EF4-FFF2-40B4-BE49-F238E27FC236}">
-                <a16:creationId xmlns:a16="http://schemas.microsoft.com/office/drawing/2014/main" id="{6C796B62-4632-4B33-BBEC-D0EB941DFD50}"/>
+                <a16:creationId xmlns:a16="http://schemas.microsoft.com/office/drawing/2014/main" id="{31FC579B-6E28-4CBA-B6C8-C2C857438F8A}"/>
               </a:ext>
             </a:extLst>
           </p:cNvPr>
@@ -7873,7 +7873,7 @@
           <p:cNvPr id="15" name="">
             <a:extLst xmlns:a="http://schemas.openxmlformats.org/drawingml/2006/main">
               <a:ext uri="{FF2B5EF4-FFF2-40B4-BE49-F238E27FC236}">
-                <a16:creationId xmlns:a16="http://schemas.microsoft.com/office/drawing/2014/main" id="{9AD7BE18-DB6A-47BB-A335-2B5F6B799E5A}"/>
+                <a16:creationId xmlns:a16="http://schemas.microsoft.com/office/drawing/2014/main" id="{C00D3891-7A77-4636-BAF7-0D70EC552CEA}"/>
               </a:ext>
             </a:extLst>
           </p:cNvPr>
@@ -7906,7 +7906,7 @@
           <p:cNvPr id="16" name="">
             <a:extLst xmlns:a="http://schemas.openxmlformats.org/drawingml/2006/main">
               <a:ext uri="{FF2B5EF4-FFF2-40B4-BE49-F238E27FC236}">
-                <a16:creationId xmlns:a16="http://schemas.microsoft.com/office/drawing/2014/main" id="{86D6AF62-B9AA-409C-85B7-E3E794B69C53}"/>
+                <a16:creationId xmlns:a16="http://schemas.microsoft.com/office/drawing/2014/main" id="{51D62215-128D-4C03-A669-C6271C118507}"/>
               </a:ext>
             </a:extLst>
           </p:cNvPr>
@@ -7956,7 +7956,7 @@
           <p:cNvPr id="17" name="">
             <a:extLst xmlns:a="http://schemas.openxmlformats.org/drawingml/2006/main">
               <a:ext uri="{FF2B5EF4-FFF2-40B4-BE49-F238E27FC236}">
-                <a16:creationId xmlns:a16="http://schemas.microsoft.com/office/drawing/2014/main" id="{1A4549BD-56B5-48EA-AAB4-EADC570D70C3}"/>
+                <a16:creationId xmlns:a16="http://schemas.microsoft.com/office/drawing/2014/main" id="{B7E3C1C0-8477-4460-9852-1A6C9D2E5DB9}"/>
               </a:ext>
             </a:extLst>
           </p:cNvPr>
@@ -8006,7 +8006,7 @@
           <p:cNvPr id="18" name="">
             <a:extLst xmlns:a="http://schemas.openxmlformats.org/drawingml/2006/main">
               <a:ext uri="{FF2B5EF4-FFF2-40B4-BE49-F238E27FC236}">
-                <a16:creationId xmlns:a16="http://schemas.microsoft.com/office/drawing/2014/main" id="{A0F89771-6FCA-4837-BE85-79C5532486E0}"/>
+                <a16:creationId xmlns:a16="http://schemas.microsoft.com/office/drawing/2014/main" id="{EEFFD693-4C79-4460-8EF1-37E6EC542F7F}"/>
               </a:ext>
             </a:extLst>
           </p:cNvPr>
@@ -8056,7 +8056,7 @@
           <p:cNvPr id="19" name="">
             <a:extLst xmlns:a="http://schemas.openxmlformats.org/drawingml/2006/main">
               <a:ext uri="{FF2B5EF4-FFF2-40B4-BE49-F238E27FC236}">
-                <a16:creationId xmlns:a16="http://schemas.microsoft.com/office/drawing/2014/main" id="{5833061D-D6E4-441C-AC50-93AE808A7CD6}"/>
+                <a16:creationId xmlns:a16="http://schemas.microsoft.com/office/drawing/2014/main" id="{B1028F78-CB18-4BA9-8876-6D1EF1BC8DCA}"/>
               </a:ext>
             </a:extLst>
           </p:cNvPr>
@@ -8106,7 +8106,7 @@
           <p:cNvPr id="20" name="">
             <a:extLst xmlns:a="http://schemas.openxmlformats.org/drawingml/2006/main">
               <a:ext uri="{FF2B5EF4-FFF2-40B4-BE49-F238E27FC236}">
-                <a16:creationId xmlns:a16="http://schemas.microsoft.com/office/drawing/2014/main" id="{5B97C460-4189-4671-AA37-F574C5C7B64E}"/>
+                <a16:creationId xmlns:a16="http://schemas.microsoft.com/office/drawing/2014/main" id="{61D755C4-BD79-476F-999D-619BEDDFA153}"/>
               </a:ext>
             </a:extLst>
           </p:cNvPr>
@@ -8154,7 +8154,7 @@
     </p:spTree>
     <p:extLst>
       <p:ext uri="{BB962C8B-B14F-4D97-AF65-F5344CB8AC3E}">
-        <p14:creationId xmlns:p14="http://schemas.microsoft.com/office/powerpoint/2010/main" val="319614563"/>
+        <p14:creationId xmlns:p14="http://schemas.microsoft.com/office/powerpoint/2010/main" val="1824079032"/>
       </p:ext>
     </p:extLst>
   </p:cSld>
@@ -8185,7 +8185,7 @@
           <p:cNvPr id="1" name="">
             <a:extLst xmlns:a="http://schemas.openxmlformats.org/drawingml/2006/main">
               <a:ext uri="{FF2B5EF4-FFF2-40B4-BE49-F238E27FC236}">
-                <a16:creationId xmlns:a16="http://schemas.microsoft.com/office/drawing/2014/main" id="{196F9422-D136-48BA-9B30-E8B321373045}"/>
+                <a16:creationId xmlns:a16="http://schemas.microsoft.com/office/drawing/2014/main" id="{1CD7C3FD-EFA8-4452-A82D-45CB1311F6CB}"/>
               </a:ext>
             </a:extLst>
           </p:cNvPr>
@@ -8235,7 +8235,7 @@
           <p:cNvPr id="2" name="">
             <a:extLst xmlns:a="http://schemas.openxmlformats.org/drawingml/2006/main">
               <a:ext uri="{FF2B5EF4-FFF2-40B4-BE49-F238E27FC236}">
-                <a16:creationId xmlns:a16="http://schemas.microsoft.com/office/drawing/2014/main" id="{61DE3853-6CDC-4CFB-B82F-0A93BE9F8CCF}"/>
+                <a16:creationId xmlns:a16="http://schemas.microsoft.com/office/drawing/2014/main" id="{038D96D4-F0C1-4275-A2CE-03B65074E955}"/>
               </a:ext>
             </a:extLst>
           </p:cNvPr>
@@ -8285,7 +8285,7 @@
           <p:cNvPr id="3" name="">
             <a:extLst xmlns:a="http://schemas.openxmlformats.org/drawingml/2006/main">
               <a:ext uri="{FF2B5EF4-FFF2-40B4-BE49-F238E27FC236}">
-                <a16:creationId xmlns:a16="http://schemas.microsoft.com/office/drawing/2014/main" id="{A2454728-7763-4DFC-9286-15051B1E7C67}"/>
+                <a16:creationId xmlns:a16="http://schemas.microsoft.com/office/drawing/2014/main" id="{3AD058EA-0D3F-4A70-B06B-B554472E5F1B}"/>
               </a:ext>
             </a:extLst>
           </p:cNvPr>
@@ -8316,7 +8316,7 @@
           <p:cNvPr id="4" name="">
             <a:extLst xmlns:a="http://schemas.openxmlformats.org/drawingml/2006/main">
               <a:ext uri="{FF2B5EF4-FFF2-40B4-BE49-F238E27FC236}">
-                <a16:creationId xmlns:a16="http://schemas.microsoft.com/office/drawing/2014/main" id="{B9F8339D-33B1-4D12-A9DF-4BD5C2B73E19}"/>
+                <a16:creationId xmlns:a16="http://schemas.microsoft.com/office/drawing/2014/main" id="{648EF7AD-AAC0-452E-BB02-F40466735CCE}"/>
               </a:ext>
             </a:extLst>
           </p:cNvPr>
@@ -8349,7 +8349,7 @@
           <p:cNvPr id="5" name="">
             <a:extLst xmlns:a="http://schemas.openxmlformats.org/drawingml/2006/main">
               <a:ext uri="{FF2B5EF4-FFF2-40B4-BE49-F238E27FC236}">
-                <a16:creationId xmlns:a16="http://schemas.microsoft.com/office/drawing/2014/main" id="{53F387C1-E64A-4588-939A-373E09361A1D}"/>
+                <a16:creationId xmlns:a16="http://schemas.microsoft.com/office/drawing/2014/main" id="{93BC1B1F-A89A-4DBE-BF90-846585BBA0FC}"/>
               </a:ext>
             </a:extLst>
           </p:cNvPr>
@@ -8399,7 +8399,7 @@
           <p:cNvPr id="6" name="">
             <a:extLst xmlns:a="http://schemas.openxmlformats.org/drawingml/2006/main">
               <a:ext uri="{FF2B5EF4-FFF2-40B4-BE49-F238E27FC236}">
-                <a16:creationId xmlns:a16="http://schemas.microsoft.com/office/drawing/2014/main" id="{CBCE2654-9CA0-4804-88BF-17D13453383D}"/>
+                <a16:creationId xmlns:a16="http://schemas.microsoft.com/office/drawing/2014/main" id="{519C9CDD-737A-46ED-BCED-85E4DC650FB3}"/>
               </a:ext>
             </a:extLst>
           </p:cNvPr>
@@ -8449,7 +8449,7 @@
           <p:cNvPr id="7" name="">
             <a:extLst xmlns:a="http://schemas.openxmlformats.org/drawingml/2006/main">
               <a:ext uri="{FF2B5EF4-FFF2-40B4-BE49-F238E27FC236}">
-                <a16:creationId xmlns:a16="http://schemas.microsoft.com/office/drawing/2014/main" id="{65E76B40-FC6F-4414-BB32-582D95B00680}"/>
+                <a16:creationId xmlns:a16="http://schemas.microsoft.com/office/drawing/2014/main" id="{3C6DE27D-E7DA-469E-8B44-74C7CEC1F46F}"/>
               </a:ext>
             </a:extLst>
           </p:cNvPr>
@@ -8482,7 +8482,7 @@
           <p:cNvPr id="8" name="">
             <a:extLst xmlns:a="http://schemas.openxmlformats.org/drawingml/2006/main">
               <a:ext uri="{FF2B5EF4-FFF2-40B4-BE49-F238E27FC236}">
-                <a16:creationId xmlns:a16="http://schemas.microsoft.com/office/drawing/2014/main" id="{5AE2C6C8-4851-4C81-9B14-B9215E3C78F6}"/>
+                <a16:creationId xmlns:a16="http://schemas.microsoft.com/office/drawing/2014/main" id="{ACB702B0-DBBA-46F7-B35C-EFF65752945C}"/>
               </a:ext>
             </a:extLst>
           </p:cNvPr>
@@ -8532,7 +8532,7 @@
           <p:cNvPr id="9" name="">
             <a:extLst xmlns:a="http://schemas.openxmlformats.org/drawingml/2006/main">
               <a:ext uri="{FF2B5EF4-FFF2-40B4-BE49-F238E27FC236}">
-                <a16:creationId xmlns:a16="http://schemas.microsoft.com/office/drawing/2014/main" id="{841F5D69-1CFF-4313-92CD-91795BE404F3}"/>
+                <a16:creationId xmlns:a16="http://schemas.microsoft.com/office/drawing/2014/main" id="{8143E588-3232-4B7A-9C56-165110BFE8D3}"/>
               </a:ext>
             </a:extLst>
           </p:cNvPr>
@@ -8582,7 +8582,7 @@
           <p:cNvPr id="10" name="">
             <a:extLst xmlns:a="http://schemas.openxmlformats.org/drawingml/2006/main">
               <a:ext uri="{FF2B5EF4-FFF2-40B4-BE49-F238E27FC236}">
-                <a16:creationId xmlns:a16="http://schemas.microsoft.com/office/drawing/2014/main" id="{39540229-D620-4AA0-8ADC-3D477EC166E5}"/>
+                <a16:creationId xmlns:a16="http://schemas.microsoft.com/office/drawing/2014/main" id="{F41E0CD0-DC1F-4F93-B6D5-A2607E0DFD89}"/>
               </a:ext>
             </a:extLst>
           </p:cNvPr>
@@ -8615,7 +8615,7 @@
           <p:cNvPr id="11" name="">
             <a:extLst xmlns:a="http://schemas.openxmlformats.org/drawingml/2006/main">
               <a:ext uri="{FF2B5EF4-FFF2-40B4-BE49-F238E27FC236}">
-                <a16:creationId xmlns:a16="http://schemas.microsoft.com/office/drawing/2014/main" id="{6EFBB1C6-F2B8-48C8-9003-28C8B5F26A71}"/>
+                <a16:creationId xmlns:a16="http://schemas.microsoft.com/office/drawing/2014/main" id="{93ED08B2-CBA4-46B4-BC01-617ABDB255FC}"/>
               </a:ext>
             </a:extLst>
           </p:cNvPr>
@@ -8665,7 +8665,7 @@
           <p:cNvPr id="12" name="">
             <a:extLst xmlns:a="http://schemas.openxmlformats.org/drawingml/2006/main">
               <a:ext uri="{FF2B5EF4-FFF2-40B4-BE49-F238E27FC236}">
-                <a16:creationId xmlns:a16="http://schemas.microsoft.com/office/drawing/2014/main" id="{53365286-C975-4879-AF82-17166594A11F}"/>
+                <a16:creationId xmlns:a16="http://schemas.microsoft.com/office/drawing/2014/main" id="{4248701A-E84A-4963-8CA4-4DF5EB5F0C3E}"/>
               </a:ext>
             </a:extLst>
           </p:cNvPr>
@@ -8715,7 +8715,7 @@
           <p:cNvPr id="13" name="">
             <a:extLst xmlns:a="http://schemas.openxmlformats.org/drawingml/2006/main">
               <a:ext uri="{FF2B5EF4-FFF2-40B4-BE49-F238E27FC236}">
-                <a16:creationId xmlns:a16="http://schemas.microsoft.com/office/drawing/2014/main" id="{43CE2AAF-B54C-478B-875F-F5AC86E018F5}"/>
+                <a16:creationId xmlns:a16="http://schemas.microsoft.com/office/drawing/2014/main" id="{D29BB9CD-C63B-4131-AB44-376F601263C1}"/>
               </a:ext>
             </a:extLst>
           </p:cNvPr>
@@ -8748,7 +8748,7 @@
           <p:cNvPr id="14" name="">
             <a:extLst xmlns:a="http://schemas.openxmlformats.org/drawingml/2006/main">
               <a:ext uri="{FF2B5EF4-FFF2-40B4-BE49-F238E27FC236}">
-                <a16:creationId xmlns:a16="http://schemas.microsoft.com/office/drawing/2014/main" id="{1B04D5E1-6DA2-412A-A9D8-17F98F11E2C8}"/>
+                <a16:creationId xmlns:a16="http://schemas.microsoft.com/office/drawing/2014/main" id="{3C646461-18FC-4CE6-A5ED-A4D0BEC79F2B}"/>
               </a:ext>
             </a:extLst>
           </p:cNvPr>
@@ -8798,7 +8798,7 @@
           <p:cNvPr id="15" name="">
             <a:extLst xmlns:a="http://schemas.openxmlformats.org/drawingml/2006/main">
               <a:ext uri="{FF2B5EF4-FFF2-40B4-BE49-F238E27FC236}">
-                <a16:creationId xmlns:a16="http://schemas.microsoft.com/office/drawing/2014/main" id="{A1A23262-0CAA-4DC4-BBE4-D5B91035971C}"/>
+                <a16:creationId xmlns:a16="http://schemas.microsoft.com/office/drawing/2014/main" id="{7A62D85C-7A75-42C1-AC49-A8E1D3284CC4}"/>
               </a:ext>
             </a:extLst>
           </p:cNvPr>
@@ -8848,7 +8848,7 @@
           <p:cNvPr id="16" name="">
             <a:extLst xmlns:a="http://schemas.openxmlformats.org/drawingml/2006/main">
               <a:ext uri="{FF2B5EF4-FFF2-40B4-BE49-F238E27FC236}">
-                <a16:creationId xmlns:a16="http://schemas.microsoft.com/office/drawing/2014/main" id="{83F2C18A-5A7C-455E-852C-22AA6988316B}"/>
+                <a16:creationId xmlns:a16="http://schemas.microsoft.com/office/drawing/2014/main" id="{669B4BBF-4B71-4E43-B917-9C923A701303}"/>
               </a:ext>
             </a:extLst>
           </p:cNvPr>
@@ -8881,7 +8881,7 @@
           <p:cNvPr id="17" name="">
             <a:extLst xmlns:a="http://schemas.openxmlformats.org/drawingml/2006/main">
               <a:ext uri="{FF2B5EF4-FFF2-40B4-BE49-F238E27FC236}">
-                <a16:creationId xmlns:a16="http://schemas.microsoft.com/office/drawing/2014/main" id="{0834B050-92C6-4F09-ACDE-8B7FFC7DED20}"/>
+                <a16:creationId xmlns:a16="http://schemas.microsoft.com/office/drawing/2014/main" id="{73390DBA-0FD8-4EE4-AD85-F1BFC20D6EFA}"/>
               </a:ext>
             </a:extLst>
           </p:cNvPr>
@@ -8931,7 +8931,7 @@
           <p:cNvPr id="18" name="">
             <a:extLst xmlns:a="http://schemas.openxmlformats.org/drawingml/2006/main">
               <a:ext uri="{FF2B5EF4-FFF2-40B4-BE49-F238E27FC236}">
-                <a16:creationId xmlns:a16="http://schemas.microsoft.com/office/drawing/2014/main" id="{8915D31F-6AA8-4446-83F9-B50C2223DE46}"/>
+                <a16:creationId xmlns:a16="http://schemas.microsoft.com/office/drawing/2014/main" id="{6C5062A9-FD35-4B39-89D3-14D89A550987}"/>
               </a:ext>
             </a:extLst>
           </p:cNvPr>
@@ -8981,7 +8981,7 @@
           <p:cNvPr id="19" name="">
             <a:extLst xmlns:a="http://schemas.openxmlformats.org/drawingml/2006/main">
               <a:ext uri="{FF2B5EF4-FFF2-40B4-BE49-F238E27FC236}">
-                <a16:creationId xmlns:a16="http://schemas.microsoft.com/office/drawing/2014/main" id="{5B59B50B-01C6-47E0-B5BB-A73379A362B1}"/>
+                <a16:creationId xmlns:a16="http://schemas.microsoft.com/office/drawing/2014/main" id="{782256B2-8451-4ADC-AD60-1062371EE5F4}"/>
               </a:ext>
             </a:extLst>
           </p:cNvPr>
@@ -9031,7 +9031,7 @@
           <p:cNvPr id="20" name="">
             <a:extLst xmlns:a="http://schemas.openxmlformats.org/drawingml/2006/main">
               <a:ext uri="{FF2B5EF4-FFF2-40B4-BE49-F238E27FC236}">
-                <a16:creationId xmlns:a16="http://schemas.microsoft.com/office/drawing/2014/main" id="{B44F8C43-3055-4840-8A93-DE755DDBC059}"/>
+                <a16:creationId xmlns:a16="http://schemas.microsoft.com/office/drawing/2014/main" id="{30742612-DF78-4C9E-9AED-702271FAB214}"/>
               </a:ext>
             </a:extLst>
           </p:cNvPr>
@@ -9079,7 +9079,7 @@
     </p:spTree>
     <p:extLst>
       <p:ext uri="{BB962C8B-B14F-4D97-AF65-F5344CB8AC3E}">
-        <p14:creationId xmlns:p14="http://schemas.microsoft.com/office/powerpoint/2010/main" val="28330188"/>
+        <p14:creationId xmlns:p14="http://schemas.microsoft.com/office/powerpoint/2010/main" val="367665803"/>
       </p:ext>
     </p:extLst>
   </p:cSld>
@@ -9110,7 +9110,7 @@
           <p:cNvPr id="1" name="">
             <a:extLst xmlns:a="http://schemas.openxmlformats.org/drawingml/2006/main">
               <a:ext uri="{FF2B5EF4-FFF2-40B4-BE49-F238E27FC236}">
-                <a16:creationId xmlns:a16="http://schemas.microsoft.com/office/drawing/2014/main" id="{FA0477EE-6143-4548-8CB8-E75B145EB5D2}"/>
+                <a16:creationId xmlns:a16="http://schemas.microsoft.com/office/drawing/2014/main" id="{A0F7E7D4-F6F3-4FF1-98BE-F3F5CB757B86}"/>
               </a:ext>
             </a:extLst>
           </p:cNvPr>
@@ -9160,7 +9160,7 @@
           <p:cNvPr id="2" name="">
             <a:extLst xmlns:a="http://schemas.openxmlformats.org/drawingml/2006/main">
               <a:ext uri="{FF2B5EF4-FFF2-40B4-BE49-F238E27FC236}">
-                <a16:creationId xmlns:a16="http://schemas.microsoft.com/office/drawing/2014/main" id="{17FF3DBE-0049-4222-961C-747053B70B86}"/>
+                <a16:creationId xmlns:a16="http://schemas.microsoft.com/office/drawing/2014/main" id="{614BC288-548A-4385-AF07-29455FBD702A}"/>
               </a:ext>
             </a:extLst>
           </p:cNvPr>
@@ -9210,7 +9210,7 @@
           <p:cNvPr id="3" name="">
             <a:extLst xmlns:a="http://schemas.openxmlformats.org/drawingml/2006/main">
               <a:ext uri="{FF2B5EF4-FFF2-40B4-BE49-F238E27FC236}">
-                <a16:creationId xmlns:a16="http://schemas.microsoft.com/office/drawing/2014/main" id="{3638596A-EB8B-47C1-B325-1FEBAC4EBCEC}"/>
+                <a16:creationId xmlns:a16="http://schemas.microsoft.com/office/drawing/2014/main" id="{DBF6800D-AEFE-4771-ADA7-F40F88CFC7F8}"/>
               </a:ext>
             </a:extLst>
           </p:cNvPr>
@@ -9241,7 +9241,7 @@
           <p:cNvPr id="4" name="">
             <a:extLst xmlns:a="http://schemas.openxmlformats.org/drawingml/2006/main">
               <a:ext uri="{FF2B5EF4-FFF2-40B4-BE49-F238E27FC236}">
-                <a16:creationId xmlns:a16="http://schemas.microsoft.com/office/drawing/2014/main" id="{D8913815-565A-4591-BE82-47E279611FB8}"/>
+                <a16:creationId xmlns:a16="http://schemas.microsoft.com/office/drawing/2014/main" id="{B3D0C751-C667-4C1E-93E9-C820034F9A4F}"/>
               </a:ext>
             </a:extLst>
           </p:cNvPr>
@@ -9274,7 +9274,7 @@
           <p:cNvPr id="5" name="">
             <a:extLst xmlns:a="http://schemas.openxmlformats.org/drawingml/2006/main">
               <a:ext uri="{FF2B5EF4-FFF2-40B4-BE49-F238E27FC236}">
-                <a16:creationId xmlns:a16="http://schemas.microsoft.com/office/drawing/2014/main" id="{8C0F18C5-2116-4C95-ADD5-C4C0B3A5E9CD}"/>
+                <a16:creationId xmlns:a16="http://schemas.microsoft.com/office/drawing/2014/main" id="{CF3DA0CE-6C2A-4B88-A818-26B2E6739741}"/>
               </a:ext>
             </a:extLst>
           </p:cNvPr>
@@ -9324,7 +9324,7 @@
           <p:cNvPr id="6" name="">
             <a:extLst xmlns:a="http://schemas.openxmlformats.org/drawingml/2006/main">
               <a:ext uri="{FF2B5EF4-FFF2-40B4-BE49-F238E27FC236}">
-                <a16:creationId xmlns:a16="http://schemas.microsoft.com/office/drawing/2014/main" id="{2ECB1DCB-1DAC-464D-B3EB-83CB82A26CCB}"/>
+                <a16:creationId xmlns:a16="http://schemas.microsoft.com/office/drawing/2014/main" id="{9E356A93-258D-4647-8D4D-170271518110}"/>
               </a:ext>
             </a:extLst>
           </p:cNvPr>
@@ -9374,7 +9374,7 @@
           <p:cNvPr id="7" name="">
             <a:extLst xmlns:a="http://schemas.openxmlformats.org/drawingml/2006/main">
               <a:ext uri="{FF2B5EF4-FFF2-40B4-BE49-F238E27FC236}">
-                <a16:creationId xmlns:a16="http://schemas.microsoft.com/office/drawing/2014/main" id="{EF927740-8B50-4087-B13D-1FC472C5AB6E}"/>
+                <a16:creationId xmlns:a16="http://schemas.microsoft.com/office/drawing/2014/main" id="{41BE0E47-1BC8-4920-AF79-FDDE2E9AB31F}"/>
               </a:ext>
             </a:extLst>
           </p:cNvPr>
@@ -9407,7 +9407,7 @@
           <p:cNvPr id="8" name="">
             <a:extLst xmlns:a="http://schemas.openxmlformats.org/drawingml/2006/main">
               <a:ext uri="{FF2B5EF4-FFF2-40B4-BE49-F238E27FC236}">
-                <a16:creationId xmlns:a16="http://schemas.microsoft.com/office/drawing/2014/main" id="{893D794D-947D-40C2-BF40-E6758B962B7C}"/>
+                <a16:creationId xmlns:a16="http://schemas.microsoft.com/office/drawing/2014/main" id="{978A1CA8-BB39-498E-8F44-F738C83B5578}"/>
               </a:ext>
             </a:extLst>
           </p:cNvPr>
@@ -9457,7 +9457,7 @@
           <p:cNvPr id="9" name="">
             <a:extLst xmlns:a="http://schemas.openxmlformats.org/drawingml/2006/main">
               <a:ext uri="{FF2B5EF4-FFF2-40B4-BE49-F238E27FC236}">
-                <a16:creationId xmlns:a16="http://schemas.microsoft.com/office/drawing/2014/main" id="{DFEA9A40-CDAC-4AEB-8CDB-1950334BE07B}"/>
+                <a16:creationId xmlns:a16="http://schemas.microsoft.com/office/drawing/2014/main" id="{3D7832F3-8505-4BF1-97CC-6EEE511E478B}"/>
               </a:ext>
             </a:extLst>
           </p:cNvPr>
@@ -9507,7 +9507,7 @@
           <p:cNvPr id="10" name="">
             <a:extLst xmlns:a="http://schemas.openxmlformats.org/drawingml/2006/main">
               <a:ext uri="{FF2B5EF4-FFF2-40B4-BE49-F238E27FC236}">
-                <a16:creationId xmlns:a16="http://schemas.microsoft.com/office/drawing/2014/main" id="{D8E7A0D7-6119-4894-9F4B-96B065E182DE}"/>
+                <a16:creationId xmlns:a16="http://schemas.microsoft.com/office/drawing/2014/main" id="{97E035E2-9385-4DCB-B591-605EE587293A}"/>
               </a:ext>
             </a:extLst>
           </p:cNvPr>
@@ -9540,7 +9540,7 @@
           <p:cNvPr id="11" name="">
             <a:extLst xmlns:a="http://schemas.openxmlformats.org/drawingml/2006/main">
               <a:ext uri="{FF2B5EF4-FFF2-40B4-BE49-F238E27FC236}">
-                <a16:creationId xmlns:a16="http://schemas.microsoft.com/office/drawing/2014/main" id="{A9E660FF-CCBD-479F-9747-DF0A04143639}"/>
+                <a16:creationId xmlns:a16="http://schemas.microsoft.com/office/drawing/2014/main" id="{179D5428-6CEA-4DBE-B1C7-CA8C75995313}"/>
               </a:ext>
             </a:extLst>
           </p:cNvPr>
@@ -9590,7 +9590,7 @@
           <p:cNvPr id="12" name="">
             <a:extLst xmlns:a="http://schemas.openxmlformats.org/drawingml/2006/main">
               <a:ext uri="{FF2B5EF4-FFF2-40B4-BE49-F238E27FC236}">
-                <a16:creationId xmlns:a16="http://schemas.microsoft.com/office/drawing/2014/main" id="{A6EF57C5-0399-4AF3-9A8D-C4CA75BA19D7}"/>
+                <a16:creationId xmlns:a16="http://schemas.microsoft.com/office/drawing/2014/main" id="{EE86ABC1-0486-4835-A30F-5C32865A119B}"/>
               </a:ext>
             </a:extLst>
           </p:cNvPr>
@@ -9640,7 +9640,7 @@
           <p:cNvPr id="13" name="">
             <a:extLst xmlns:a="http://schemas.openxmlformats.org/drawingml/2006/main">
               <a:ext uri="{FF2B5EF4-FFF2-40B4-BE49-F238E27FC236}">
-                <a16:creationId xmlns:a16="http://schemas.microsoft.com/office/drawing/2014/main" id="{0514995D-AFD3-4E8C-8FEF-F5E5E1C31E52}"/>
+                <a16:creationId xmlns:a16="http://schemas.microsoft.com/office/drawing/2014/main" id="{119DA14E-1366-42DF-87E0-8B7C4165441C}"/>
               </a:ext>
             </a:extLst>
           </p:cNvPr>
@@ -9673,7 +9673,7 @@
           <p:cNvPr id="14" name="">
             <a:extLst xmlns:a="http://schemas.openxmlformats.org/drawingml/2006/main">
               <a:ext uri="{FF2B5EF4-FFF2-40B4-BE49-F238E27FC236}">
-                <a16:creationId xmlns:a16="http://schemas.microsoft.com/office/drawing/2014/main" id="{D6C2BE6C-523D-4577-B319-3013C616AFC2}"/>
+                <a16:creationId xmlns:a16="http://schemas.microsoft.com/office/drawing/2014/main" id="{82877382-9F7A-4637-BBF6-417DC566C5FB}"/>
               </a:ext>
             </a:extLst>
           </p:cNvPr>
@@ -9723,7 +9723,7 @@
           <p:cNvPr id="15" name="">
             <a:extLst xmlns:a="http://schemas.openxmlformats.org/drawingml/2006/main">
               <a:ext uri="{FF2B5EF4-FFF2-40B4-BE49-F238E27FC236}">
-                <a16:creationId xmlns:a16="http://schemas.microsoft.com/office/drawing/2014/main" id="{F2653DD9-512C-4717-9A5A-3962DF2B7F8B}"/>
+                <a16:creationId xmlns:a16="http://schemas.microsoft.com/office/drawing/2014/main" id="{4DE04B61-5218-43C6-9C99-AE4D9B369CA4}"/>
               </a:ext>
             </a:extLst>
           </p:cNvPr>
@@ -9773,7 +9773,7 @@
           <p:cNvPr id="16" name="">
             <a:extLst xmlns:a="http://schemas.openxmlformats.org/drawingml/2006/main">
               <a:ext uri="{FF2B5EF4-FFF2-40B4-BE49-F238E27FC236}">
-                <a16:creationId xmlns:a16="http://schemas.microsoft.com/office/drawing/2014/main" id="{B2D10870-EC18-4756-8313-D6F412A85333}"/>
+                <a16:creationId xmlns:a16="http://schemas.microsoft.com/office/drawing/2014/main" id="{15228D30-35FD-447B-B0DE-6837E48E940A}"/>
               </a:ext>
             </a:extLst>
           </p:cNvPr>
@@ -9823,7 +9823,7 @@
           <p:cNvPr id="17" name="">
             <a:extLst xmlns:a="http://schemas.openxmlformats.org/drawingml/2006/main">
               <a:ext uri="{FF2B5EF4-FFF2-40B4-BE49-F238E27FC236}">
-                <a16:creationId xmlns:a16="http://schemas.microsoft.com/office/drawing/2014/main" id="{9A417560-598B-46E4-A578-A512707BACAA}"/>
+                <a16:creationId xmlns:a16="http://schemas.microsoft.com/office/drawing/2014/main" id="{BFA8B10E-31B0-4BB6-8E56-43D49F7D47A2}"/>
               </a:ext>
             </a:extLst>
           </p:cNvPr>
@@ -9873,7 +9873,7 @@
           <p:cNvPr id="18" name="">
             <a:extLst xmlns:a="http://schemas.openxmlformats.org/drawingml/2006/main">
               <a:ext uri="{FF2B5EF4-FFF2-40B4-BE49-F238E27FC236}">
-                <a16:creationId xmlns:a16="http://schemas.microsoft.com/office/drawing/2014/main" id="{29C53B0D-55BC-415D-AA94-AE866A4D3651}"/>
+                <a16:creationId xmlns:a16="http://schemas.microsoft.com/office/drawing/2014/main" id="{9A8E2BF2-77B3-40B4-89AA-2268AAAA2A3B}"/>
               </a:ext>
             </a:extLst>
           </p:cNvPr>
@@ -9921,7 +9921,7 @@
     </p:spTree>
     <p:extLst>
       <p:ext uri="{BB962C8B-B14F-4D97-AF65-F5344CB8AC3E}">
-        <p14:creationId xmlns:p14="http://schemas.microsoft.com/office/powerpoint/2010/main" val="658382186"/>
+        <p14:creationId xmlns:p14="http://schemas.microsoft.com/office/powerpoint/2010/main" val="1220311907"/>
       </p:ext>
     </p:extLst>
   </p:cSld>

</xml_diff>